<commit_message>
docs: add query structure tuning to portfolio materials
</commit_message>
<xml_diff>
--- a/docs/portfolio/settlement-benchmark-portfolio.pptx
+++ b/docs/portfolio/settlement-benchmark-portfolio.pptx
@@ -2,7 +2,7 @@
 <file path=ppt/presentation.xml><?xml version="1.0" encoding="utf-8"?>
 <p:presentation xmlns:a="http://schemas.openxmlformats.org/drawingml/2006/main" xmlns:r="http://schemas.openxmlformats.org/officeDocument/2006/relationships" xmlns:p="http://schemas.openxmlformats.org/presentationml/2006/main">
   <p:sldMasterIdLst>
-    <p:sldMasterId id="2147483648" r:id="rId10"/>
+    <p:sldMasterId id="2147483648" r:id="rId11"/>
   </p:sldMasterIdLst>
   <p:sldIdLst>
     <p:sldId id="257" r:id="rId1"/>
@@ -14,6 +14,7 @@
     <p:sldId id="263" r:id="rId7"/>
     <p:sldId id="264" r:id="rId8"/>
     <p:sldId id="265" r:id="rId9"/>
+    <p:sldId id="266" r:id="rId10"/>
   </p:sldIdLst>
   <p:sldSz cx="12191695" cy="6858000" type="wide"/>
   <p:notesSz cx="6858000" cy="9144000"/>
@@ -680,6 +681,617 @@
 </p:sld>
 </file>
 
+<file path=ppt/slides/slide10.xml><?xml version="1.0" encoding="utf-8"?>
+<p:sld xmlns:a="http://schemas.openxmlformats.org/drawingml/2006/main" xmlns:r="http://schemas.openxmlformats.org/officeDocument/2006/relationships" xmlns:p="http://schemas.openxmlformats.org/presentationml/2006/main">
+  <p:cSld>
+    <p:spTree>
+      <p:nvGrpSpPr>
+        <p:cNvPr id="1" name=""/>
+        <p:cNvGrpSpPr/>
+        <p:nvPr/>
+      </p:nvGrpSpPr>
+      <p:grpSpPr>
+        <a:xfrm>
+          <a:off x="0" y="0"/>
+          <a:ext cx="0" cy="0"/>
+          <a:chOff x="0" y="0"/>
+          <a:chExt cx="0" cy="0"/>
+        </a:xfrm>
+      </p:grpSpPr>
+      <p:sp>
+        <p:nvSpPr>
+          <p:cNvPr id="2" name="Shape 2"/>
+          <p:cNvSpPr txBox="1"/>
+          <p:nvPr/>
+        </p:nvSpPr>
+        <p:spPr>
+          <a:xfrm>
+            <a:off x="0" y="0"/>
+            <a:ext cx="12191695" cy="6858000"/>
+          </a:xfrm>
+          <a:prstGeom prst="rect">
+            <a:avLst/>
+          </a:prstGeom>
+          <a:solidFill>
+            <a:srgbClr val="F8FAFC"/>
+          </a:solidFill>
+          <a:ln w="9525">
+            <a:solidFill>
+              <a:srgbClr val="F8FAFC"/>
+            </a:solidFill>
+          </a:ln>
+        </p:spPr>
+        <p:txBody>
+          <a:bodyPr wrap="square" anchor="t" lIns="91440" tIns="68580" rIns="91440" bIns="68580"/>
+          <a:lstStyle/>
+          <a:p>
+            <a:r>
+              <a:rPr lang="ko-KR" sz="1800" b="0">
+                <a:solidFill>
+                  <a:srgbClr val="0F172A"/>
+                </a:solidFill>
+                <a:latin typeface="Aptos"/>
+                <a:ea typeface="Malgun Gothic"/>
+              </a:rPr>
+              <a:t/>
+            </a:r>
+          </a:p>
+        </p:txBody>
+      </p:sp>
+      <p:sp>
+        <p:nvSpPr>
+          <p:cNvPr id="3" name="Shape 3"/>
+          <p:cNvSpPr txBox="1"/>
+          <p:nvPr/>
+        </p:nvSpPr>
+        <p:spPr>
+          <a:xfrm>
+            <a:off x="0" y="0"/>
+            <a:ext cx="164592" cy="6858000"/>
+          </a:xfrm>
+          <a:prstGeom prst="rect">
+            <a:avLst/>
+          </a:prstGeom>
+          <a:solidFill>
+            <a:srgbClr val="2563EB"/>
+          </a:solidFill>
+          <a:ln w="9525">
+            <a:solidFill>
+              <a:srgbClr val="2563EB"/>
+            </a:solidFill>
+          </a:ln>
+        </p:spPr>
+        <p:txBody>
+          <a:bodyPr wrap="square" anchor="t" lIns="91440" tIns="68580" rIns="91440" bIns="68580"/>
+          <a:lstStyle/>
+          <a:p>
+            <a:r>
+              <a:rPr lang="ko-KR" sz="1800" b="0">
+                <a:solidFill>
+                  <a:srgbClr val="0F172A"/>
+                </a:solidFill>
+                <a:latin typeface="Aptos"/>
+                <a:ea typeface="Malgun Gothic"/>
+              </a:rPr>
+              <a:t/>
+            </a:r>
+          </a:p>
+        </p:txBody>
+      </p:sp>
+      <p:sp>
+        <p:nvSpPr>
+          <p:cNvPr id="4" name="Shape 4"/>
+          <p:cNvSpPr txBox="1"/>
+          <p:nvPr/>
+        </p:nvSpPr>
+        <p:spPr>
+          <a:xfrm>
+            <a:off x="502920" y="292608"/>
+            <a:ext cx="7955279" cy="411480"/>
+          </a:xfrm>
+          <a:prstGeom prst="rect">
+            <a:avLst/>
+          </a:prstGeom>
+          <a:noFill/>
+          <a:ln>
+            <a:noFill/>
+          </a:ln>
+        </p:spPr>
+        <p:txBody>
+          <a:bodyPr wrap="square" anchor="t" lIns="91440" tIns="68580" rIns="91440" bIns="68580"/>
+          <a:lstStyle/>
+          <a:p>
+            <a:r>
+              <a:rPr lang="ko-KR" sz="2500" b="1">
+                <a:solidFill>
+                  <a:srgbClr val="0F172A"/>
+                </a:solidFill>
+                <a:latin typeface="Aptos"/>
+                <a:ea typeface="Malgun Gothic"/>
+              </a:rPr>
+              <a:t>최종 성능 결과와 배운 점</a:t>
+            </a:r>
+          </a:p>
+        </p:txBody>
+      </p:sp>
+      <p:sp>
+        <p:nvSpPr>
+          <p:cNvPr id="5" name="Shape 5"/>
+          <p:cNvSpPr txBox="1"/>
+          <p:nvPr/>
+        </p:nvSpPr>
+        <p:spPr>
+          <a:xfrm>
+            <a:off x="530352" y="786384"/>
+            <a:ext cx="8778240" cy="274320"/>
+          </a:xfrm>
+          <a:prstGeom prst="rect">
+            <a:avLst/>
+          </a:prstGeom>
+          <a:noFill/>
+          <a:ln>
+            <a:noFill/>
+          </a:ln>
+        </p:spPr>
+        <p:txBody>
+          <a:bodyPr wrap="square" anchor="t" lIns="91440" tIns="68580" rIns="91440" bIns="68580"/>
+          <a:lstStyle/>
+          <a:p>
+            <a:r>
+              <a:rPr lang="ko-KR" sz="1200" b="1">
+                <a:solidFill>
+                  <a:srgbClr val="2563EB"/>
+                </a:solidFill>
+                <a:latin typeface="Aptos"/>
+                <a:ea typeface="Malgun Gothic"/>
+              </a:rPr>
+              <a:t>성능 개선 후에도 처리 건수, Settlement 건수, 총액 동일성을 확인</a:t>
+            </a:r>
+          </a:p>
+        </p:txBody>
+      </p:sp>
+      <p:sp>
+        <p:nvSpPr>
+          <p:cNvPr id="6" name="Shape 6"/>
+          <p:cNvSpPr txBox="1"/>
+          <p:nvPr/>
+        </p:nvSpPr>
+        <p:spPr>
+          <a:xfrm>
+            <a:off x="594360" y="1143000"/>
+            <a:ext cx="3566160" cy="1417320"/>
+          </a:xfrm>
+          <a:prstGeom prst="roundRect">
+            <a:avLst/>
+          </a:prstGeom>
+          <a:solidFill>
+            <a:srgbClr val="FFFFFF"/>
+          </a:solidFill>
+          <a:ln w="9525">
+            <a:solidFill>
+              <a:srgbClr val="BFDBFE"/>
+            </a:solidFill>
+          </a:ln>
+        </p:spPr>
+        <p:txBody>
+          <a:bodyPr wrap="square" anchor="ctr" lIns="91440" tIns="68580" rIns="91440" bIns="68580"/>
+          <a:lstStyle/>
+          <a:p>
+            <a:r>
+              <a:rPr lang="ko-KR" sz="1500" b="1">
+                <a:solidFill>
+                  <a:srgbClr val="0F172A"/>
+                </a:solidFill>
+                <a:latin typeface="Aptos"/>
+                <a:ea typeface="Malgun Gothic"/>
+              </a:rPr>
+              <a:t>100만 건</a:t>
+            </a:r>
+          </a:p>
+          <a:p>
+            <a:r>
+              <a:rPr lang="ko-KR" sz="1500" b="1">
+                <a:solidFill>
+                  <a:srgbClr val="0F172A"/>
+                </a:solidFill>
+                <a:latin typeface="Aptos"/>
+                <a:ea typeface="Malgun Gothic"/>
+              </a:rPr>
+              <a:t>BASIC_LOOP 8,253ms</a:t>
+            </a:r>
+          </a:p>
+          <a:p>
+            <a:r>
+              <a:rPr lang="ko-KR" sz="1500" b="1">
+                <a:solidFill>
+                  <a:srgbClr val="0F172A"/>
+                </a:solidFill>
+                <a:latin typeface="Aptos"/>
+                <a:ea typeface="Malgun Gothic"/>
+              </a:rPr>
+              <a:t>GROUP_BY_QUERY 899ms</a:t>
+            </a:r>
+          </a:p>
+          <a:p>
+            <a:r>
+              <a:rPr lang="ko-KR" sz="1500" b="1">
+                <a:solidFill>
+                  <a:srgbClr val="0F172A"/>
+                </a:solidFill>
+                <a:latin typeface="Aptos"/>
+                <a:ea typeface="Malgun Gothic"/>
+              </a:rPr>
+              <a:t>GROUP_BY_BULK_SAVE 798ms</a:t>
+            </a:r>
+          </a:p>
+        </p:txBody>
+      </p:sp>
+      <p:sp>
+        <p:nvSpPr>
+          <p:cNvPr id="7" name="Shape 7"/>
+          <p:cNvSpPr txBox="1"/>
+          <p:nvPr/>
+        </p:nvSpPr>
+        <p:spPr>
+          <a:xfrm>
+            <a:off x="4343400" y="1143000"/>
+            <a:ext cx="3566160" cy="1417320"/>
+          </a:xfrm>
+          <a:prstGeom prst="roundRect">
+            <a:avLst/>
+          </a:prstGeom>
+          <a:solidFill>
+            <a:srgbClr val="FFFFFF"/>
+          </a:solidFill>
+          <a:ln w="9525">
+            <a:solidFill>
+              <a:srgbClr val="BFDBFE"/>
+            </a:solidFill>
+          </a:ln>
+        </p:spPr>
+        <p:txBody>
+          <a:bodyPr wrap="square" anchor="ctr" lIns="91440" tIns="68580" rIns="91440" bIns="68580"/>
+          <a:lstStyle/>
+          <a:p>
+            <a:r>
+              <a:rPr lang="ko-KR" sz="1300" b="1">
+                <a:solidFill>
+                  <a:srgbClr val="0F172A"/>
+                </a:solidFill>
+                <a:latin typeface="Aptos"/>
+                <a:ea typeface="Malgun Gothic"/>
+              </a:rPr>
+              <a:t>날짜 분산 1000만 건</a:t>
+            </a:r>
+          </a:p>
+          <a:p>
+            <a:r>
+              <a:rPr lang="ko-KR" sz="1300" b="1">
+                <a:solidFill>
+                  <a:srgbClr val="0F172A"/>
+                </a:solidFill>
+                <a:latin typeface="Aptos"/>
+                <a:ea typeface="Malgun Gothic"/>
+              </a:rPr>
+              <a:t>EXPLAIN 2,242.501ms → 74.988ms</a:t>
+            </a:r>
+          </a:p>
+          <a:p>
+            <a:r>
+              <a:rPr lang="ko-KR" sz="1300" b="1">
+                <a:solidFill>
+                  <a:srgbClr val="0F172A"/>
+                </a:solidFill>
+                <a:latin typeface="Aptos"/>
+                <a:ea typeface="Malgun Gothic"/>
+              </a:rPr>
+              <a:t>API GQ 3,021.333ms → 1,627.667ms</a:t>
+            </a:r>
+          </a:p>
+          <a:p>
+            <a:r>
+              <a:rPr lang="ko-KR" sz="1300" b="1">
+                <a:solidFill>
+                  <a:srgbClr val="0F172A"/>
+                </a:solidFill>
+                <a:latin typeface="Aptos"/>
+                <a:ea typeface="Malgun Gothic"/>
+              </a:rPr>
+              <a:t>API GBS 2,478.333ms → 2,058.000ms</a:t>
+            </a:r>
+          </a:p>
+        </p:txBody>
+      </p:sp>
+      <p:sp>
+        <p:nvSpPr>
+          <p:cNvPr id="8" name="Shape 8"/>
+          <p:cNvSpPr txBox="1"/>
+          <p:nvPr/>
+        </p:nvSpPr>
+        <p:spPr>
+          <a:xfrm>
+            <a:off x="8092440" y="1143000"/>
+            <a:ext cx="3566160" cy="1417320"/>
+          </a:xfrm>
+          <a:prstGeom prst="roundRect">
+            <a:avLst/>
+          </a:prstGeom>
+          <a:solidFill>
+            <a:srgbClr val="FFFFFF"/>
+          </a:solidFill>
+          <a:ln w="9525">
+            <a:solidFill>
+              <a:srgbClr val="BFDBFE"/>
+            </a:solidFill>
+          </a:ln>
+        </p:spPr>
+        <p:txBody>
+          <a:bodyPr wrap="square" anchor="ctr" lIns="91440" tIns="68580" rIns="91440" bIns="68580"/>
+          <a:lstStyle/>
+          <a:p>
+            <a:r>
+              <a:rPr lang="ko-KR" sz="1500" b="1">
+                <a:solidFill>
+                  <a:srgbClr val="0F172A"/>
+                </a:solidFill>
+                <a:latin typeface="Aptos"/>
+                <a:ea typeface="Malgun Gothic"/>
+              </a:rPr>
+              <a:t>SEQUENCE 변경 후</a:t>
+            </a:r>
+          </a:p>
+          <a:p>
+            <a:r>
+              <a:rPr lang="ko-KR" sz="1500" b="1">
+                <a:solidFill>
+                  <a:srgbClr val="0F172A"/>
+                </a:solidFill>
+                <a:latin typeface="Aptos"/>
+                <a:ea typeface="Malgun Gothic"/>
+              </a:rPr>
+              <a:t>GROUP_BY_QUERY 755.662ms</a:t>
+            </a:r>
+          </a:p>
+          <a:p>
+            <a:r>
+              <a:rPr lang="ko-KR" sz="1500" b="1">
+                <a:solidFill>
+                  <a:srgbClr val="0F172A"/>
+                </a:solidFill>
+                <a:latin typeface="Aptos"/>
+                <a:ea typeface="Malgun Gothic"/>
+              </a:rPr>
+              <a:t>GROUP_BY_BULK_SAVE 696.352ms</a:t>
+            </a:r>
+          </a:p>
+        </p:txBody>
+      </p:sp>
+      <p:sp>
+        <p:nvSpPr>
+          <p:cNvPr id="9" name="Shape 9"/>
+          <p:cNvSpPr txBox="1"/>
+          <p:nvPr/>
+        </p:nvSpPr>
+        <p:spPr>
+          <a:xfrm>
+            <a:off x="777240" y="3108960"/>
+            <a:ext cx="5212080" cy="1691640"/>
+          </a:xfrm>
+          <a:prstGeom prst="roundRect">
+            <a:avLst/>
+          </a:prstGeom>
+          <a:solidFill>
+            <a:srgbClr val="EFF6FF"/>
+          </a:solidFill>
+          <a:ln w="9525">
+            <a:solidFill>
+              <a:srgbClr val="BFDBFE"/>
+            </a:solidFill>
+          </a:ln>
+        </p:spPr>
+        <p:txBody>
+          <a:bodyPr wrap="square" anchor="t" lIns="91440" tIns="68580" rIns="91440" bIns="68580"/>
+          <a:lstStyle/>
+          <a:p>
+            <a:pPr marL="285750" indent="-171450">
+              <a:buChar char="•"/>
+            </a:pPr>
+            <a:r>
+              <a:rPr lang="ko-KR" sz="1500">
+                <a:solidFill>
+                  <a:srgbClr val="0F172A"/>
+                </a:solidFill>
+                <a:latin typeface="Aptos"/>
+                <a:ea typeface="Malgun Gothic"/>
+              </a:rPr>
+              <a:t>EXPLAIN, SQL 로그, 구간별 측정으로 판단</a:t>
+            </a:r>
+          </a:p>
+          <a:p>
+            <a:pPr marL="285750" indent="-171450">
+              <a:buChar char="•"/>
+            </a:pPr>
+            <a:r>
+              <a:rPr lang="ko-KR" sz="1500">
+                <a:solidFill>
+                  <a:srgbClr val="0F172A"/>
+                </a:solidFill>
+                <a:latin typeface="Aptos"/>
+                <a:ea typeface="Malgun Gothic"/>
+              </a:rPr>
+              <a:t>processedCount=322,581 확인</a:t>
+            </a:r>
+          </a:p>
+          <a:p>
+            <a:pPr marL="285750" indent="-171450">
+              <a:buChar char="•"/>
+            </a:pPr>
+            <a:r>
+              <a:rPr lang="ko-KR" sz="1500">
+                <a:solidFill>
+                  <a:srgbClr val="0F172A"/>
+                </a:solidFill>
+                <a:latin typeface="Aptos"/>
+                <a:ea typeface="Malgun Gothic"/>
+              </a:rPr>
+              <a:t>Settlement 10,000건 확인</a:t>
+            </a:r>
+          </a:p>
+        </p:txBody>
+      </p:sp>
+      <p:sp>
+        <p:nvSpPr>
+          <p:cNvPr id="10" name="Shape 10"/>
+          <p:cNvSpPr txBox="1"/>
+          <p:nvPr/>
+        </p:nvSpPr>
+        <p:spPr>
+          <a:xfrm>
+            <a:off x="6263640" y="3108960"/>
+            <a:ext cx="5074920" cy="1691640"/>
+          </a:xfrm>
+          <a:prstGeom prst="roundRect">
+            <a:avLst/>
+          </a:prstGeom>
+          <a:solidFill>
+            <a:srgbClr val="EFF6FF"/>
+          </a:solidFill>
+          <a:ln w="9525">
+            <a:solidFill>
+              <a:srgbClr val="BFDBFE"/>
+            </a:solidFill>
+          </a:ln>
+        </p:spPr>
+        <p:txBody>
+          <a:bodyPr wrap="square" anchor="t" lIns="91440" tIns="68580" rIns="91440" bIns="68580"/>
+          <a:lstStyle/>
+          <a:p>
+            <a:pPr marL="285750" indent="-171450">
+              <a:buChar char="•"/>
+            </a:pPr>
+            <a:r>
+              <a:rPr lang="ko-KR" sz="1500">
+                <a:solidFill>
+                  <a:srgbClr val="0F172A"/>
+                </a:solidFill>
+                <a:latin typeface="Aptos"/>
+                <a:ea typeface="Malgun Gothic"/>
+              </a:rPr>
+              <a:t>결제금액/취소금액/수수료/최종 정산금액 동일</a:t>
+            </a:r>
+          </a:p>
+          <a:p>
+            <a:pPr marL="285750" indent="-171450">
+              <a:buChar char="•"/>
+            </a:pPr>
+            <a:r>
+              <a:rPr lang="ko-KR" sz="1500">
+                <a:solidFill>
+                  <a:srgbClr val="0F172A"/>
+                </a:solidFill>
+                <a:latin typeface="Aptos"/>
+                <a:ea typeface="Malgun Gothic"/>
+              </a:rPr>
+              <a:t>중복 실행 차단과 실패 이력 보존</a:t>
+            </a:r>
+          </a:p>
+          <a:p>
+            <a:pPr marL="285750" indent="-171450">
+              <a:buChar char="•"/>
+            </a:pPr>
+            <a:r>
+              <a:rPr lang="ko-KR" sz="1500">
+                <a:solidFill>
+                  <a:srgbClr val="0F172A"/>
+                </a:solidFill>
+                <a:latin typeface="Aptos"/>
+                <a:ea typeface="Malgun Gothic"/>
+              </a:rPr>
+              <a:t>성능과 정합성을 함께 검증</a:t>
+            </a:r>
+          </a:p>
+        </p:txBody>
+      </p:sp>
+      <p:sp>
+        <p:nvSpPr>
+          <p:cNvPr id="11" name="Shape 11"/>
+          <p:cNvSpPr txBox="1"/>
+          <p:nvPr/>
+        </p:nvSpPr>
+        <p:spPr>
+          <a:xfrm>
+            <a:off x="502920" y="6446520"/>
+            <a:ext cx="4572000" cy="228600"/>
+          </a:xfrm>
+          <a:prstGeom prst="rect">
+            <a:avLst/>
+          </a:prstGeom>
+          <a:noFill/>
+          <a:ln>
+            <a:noFill/>
+          </a:ln>
+        </p:spPr>
+        <p:txBody>
+          <a:bodyPr wrap="square" anchor="t" lIns="91440" tIns="68580" rIns="91440" bIns="68580"/>
+          <a:lstStyle/>
+          <a:p>
+            <a:r>
+              <a:rPr lang="ko-KR" sz="900" b="0">
+                <a:solidFill>
+                  <a:srgbClr val="64748B"/>
+                </a:solidFill>
+                <a:latin typeface="Aptos"/>
+                <a:ea typeface="Malgun Gothic"/>
+              </a:rPr>
+              <a:t>결과 요약</a:t>
+            </a:r>
+          </a:p>
+        </p:txBody>
+      </p:sp>
+      <p:sp>
+        <p:nvSpPr>
+          <p:cNvPr id="12" name="Shape 12"/>
+          <p:cNvSpPr txBox="1"/>
+          <p:nvPr/>
+        </p:nvSpPr>
+        <p:spPr>
+          <a:xfrm>
+            <a:off x="11109960" y="6446520"/>
+            <a:ext cx="640080" cy="228600"/>
+          </a:xfrm>
+          <a:prstGeom prst="rect">
+            <a:avLst/>
+          </a:prstGeom>
+          <a:noFill/>
+          <a:ln>
+            <a:noFill/>
+          </a:ln>
+        </p:spPr>
+        <p:txBody>
+          <a:bodyPr wrap="square" anchor="ctr" lIns="91440" tIns="68580" rIns="91440" bIns="68580"/>
+          <a:lstStyle/>
+          <a:p>
+            <a:r>
+              <a:rPr lang="ko-KR" sz="900" b="0">
+                <a:solidFill>
+                  <a:srgbClr val="64748B"/>
+                </a:solidFill>
+                <a:latin typeface="Aptos"/>
+                <a:ea typeface="Malgun Gothic"/>
+              </a:rPr>
+              <a:t>10</a:t>
+            </a:r>
+          </a:p>
+        </p:txBody>
+      </p:sp>
+    </p:spTree>
+  </p:cSld>
+  <p:clrMapOvr>
+    <a:masterClrMapping/>
+  </p:clrMapOvr>
+</p:sld>
+</file>
+
 <file path=ppt/slides/slide2.xml><?xml version="1.0" encoding="utf-8"?>
 <p:sld xmlns:a="http://schemas.openxmlformats.org/drawingml/2006/main" xmlns:r="http://schemas.openxmlformats.org/officeDocument/2006/relationships" xmlns:p="http://schemas.openxmlformats.org/presentationml/2006/main">
   <p:cSld>
@@ -3296,7 +3908,7 @@
                 <a:latin typeface="Aptos"/>
                 <a:ea typeface="Malgun Gothic"/>
               </a:rPr>
-              <a:t>트러블슈팅 1: work_mem과 temp spill</a:t>
+              <a:t>쿼리 구조 개선: 조인 후 집계에서 선집계 후 조인으로</a:t>
             </a:r>
           </a:p>
         </p:txBody>
@@ -3332,7 +3944,7 @@
                 <a:latin typeface="Aptos"/>
                 <a:ea typeface="Malgun Gothic"/>
               </a:rPr>
-              <a:t>병목을 감으로 판단하지 않고 EXPLAIN과 temp 지표로 확인</a:t>
+              <a:t>정산에 필요한 Payment 집계를 먼저 줄인 뒤 Merchant 정보를 조인</a:t>
             </a:r>
           </a:p>
         </p:txBody>
@@ -3346,17 +3958,17 @@
         <p:spPr>
           <a:xfrm>
             <a:off x="685800" y="1234440"/>
-            <a:ext cx="10881360" cy="411480"/>
+            <a:ext cx="5257800" cy="1234440"/>
           </a:xfrm>
           <a:prstGeom prst="roundRect">
             <a:avLst/>
           </a:prstGeom>
           <a:solidFill>
-            <a:srgbClr val="FEF3C7"/>
-          </a:solidFill>
-          <a:ln w="9525">
-            <a:solidFill>
-              <a:srgbClr val="FDE68A"/>
+            <a:srgbClr val="FEE2E2"/>
+          </a:solidFill>
+          <a:ln w="9525">
+            <a:solidFill>
+              <a:srgbClr val="FCA5A5"/>
             </a:solidFill>
           </a:ln>
         </p:spPr>
@@ -3372,7 +3984,43 @@
                 <a:latin typeface="Aptos"/>
                 <a:ea typeface="Malgun Gothic"/>
               </a:rPr>
-              <a:t>HashAggregate temp spill: 기본 4MB에서는 batches=5, temp read/write 발생</a:t>
+              <a:t>기존 구조</a:t>
+            </a:r>
+          </a:p>
+          <a:p>
+            <a:r>
+              <a:rPr lang="ko-KR" sz="1600" b="1">
+                <a:solidFill>
+                  <a:srgbClr val="0F172A"/>
+                </a:solidFill>
+                <a:latin typeface="Aptos"/>
+                <a:ea typeface="Malgun Gothic"/>
+              </a:rPr>
+              <a:t>payments + merchants 조인</a:t>
+            </a:r>
+          </a:p>
+          <a:p>
+            <a:r>
+              <a:rPr lang="ko-KR" sz="1600" b="1">
+                <a:solidFill>
+                  <a:srgbClr val="0F172A"/>
+                </a:solidFill>
+                <a:latin typeface="Aptos"/>
+                <a:ea typeface="Malgun Gothic"/>
+              </a:rPr>
+              <a:t>→ GROUP BY</a:t>
+            </a:r>
+          </a:p>
+          <a:p>
+            <a:r>
+              <a:rPr lang="ko-KR" sz="1600" b="1">
+                <a:solidFill>
+                  <a:srgbClr val="0F172A"/>
+                </a:solidFill>
+                <a:latin typeface="Aptos"/>
+                <a:ea typeface="Malgun Gothic"/>
+              </a:rPr>
+              <a:t>→ temp spill 증가</a:t>
             </a:r>
           </a:p>
         </p:txBody>
@@ -3385,106 +4033,94 @@
         </p:nvSpPr>
         <p:spPr>
           <a:xfrm>
-            <a:off x="731520" y="1874519"/>
-            <a:ext cx="10744200" cy="1965960"/>
+            <a:off x="6263640" y="1234440"/>
+            <a:ext cx="5257800" cy="1234440"/>
           </a:xfrm>
           <a:prstGeom prst="roundRect">
             <a:avLst/>
           </a:prstGeom>
           <a:solidFill>
+            <a:srgbClr val="DCFCE7"/>
+          </a:solidFill>
+          <a:ln w="9525">
+            <a:solidFill>
+              <a:srgbClr val="86EFAC"/>
+            </a:solidFill>
+          </a:ln>
+        </p:spPr>
+        <p:txBody>
+          <a:bodyPr wrap="square" anchor="ctr" lIns="91440" tIns="68580" rIns="91440" bIns="68580"/>
+          <a:lstStyle/>
+          <a:p>
+            <a:r>
+              <a:rPr lang="ko-KR" sz="1600" b="1">
+                <a:solidFill>
+                  <a:srgbClr val="0F172A"/>
+                </a:solidFill>
+                <a:latin typeface="Aptos"/>
+                <a:ea typeface="Malgun Gothic"/>
+              </a:rPr>
+              <a:t>개선 구조</a:t>
+            </a:r>
+          </a:p>
+          <a:p>
+            <a:r>
+              <a:rPr lang="ko-KR" sz="1600" b="1">
+                <a:solidFill>
+                  <a:srgbClr val="0F172A"/>
+                </a:solidFill>
+                <a:latin typeface="Aptos"/>
+                <a:ea typeface="Malgun Gothic"/>
+              </a:rPr>
+              <a:t>payments 선집계</a:t>
+            </a:r>
+          </a:p>
+          <a:p>
+            <a:r>
+              <a:rPr lang="ko-KR" sz="1600" b="1">
+                <a:solidFill>
+                  <a:srgbClr val="0F172A"/>
+                </a:solidFill>
+                <a:latin typeface="Aptos"/>
+                <a:ea typeface="Malgun Gothic"/>
+              </a:rPr>
+              <a:t>→ merchants 조인</a:t>
+            </a:r>
+          </a:p>
+          <a:p>
+            <a:r>
+              <a:rPr lang="ko-KR" sz="1600" b="1">
+                <a:solidFill>
+                  <a:srgbClr val="0F172A"/>
+                </a:solidFill>
+                <a:latin typeface="Aptos"/>
+                <a:ea typeface="Malgun Gothic"/>
+              </a:rPr>
+              <a:t>→ 중간 데이터 감소</a:t>
+            </a:r>
+          </a:p>
+        </p:txBody>
+      </p:sp>
+      <p:sp>
+        <p:nvSpPr>
+          <p:cNvPr id="8" name="Shape 8"/>
+          <p:cNvSpPr txBox="1"/>
+          <p:nvPr/>
+        </p:nvSpPr>
+        <p:spPr>
+          <a:xfrm>
+            <a:off x="868680" y="2788920"/>
+            <a:ext cx="4892040" cy="1005840"/>
+          </a:xfrm>
+          <a:prstGeom prst="roundRect">
+            <a:avLst/>
+          </a:prstGeom>
+          <a:solidFill>
             <a:srgbClr val="FFFFFF"/>
           </a:solidFill>
           <a:ln w="9525">
             <a:solidFill>
-              <a:srgbClr val="CBD5E1"/>
-            </a:solidFill>
-          </a:ln>
-        </p:spPr>
-        <p:txBody>
-          <a:bodyPr wrap="square" anchor="t" lIns="91440" tIns="68580" rIns="91440" bIns="68580"/>
-          <a:lstStyle/>
-          <a:p>
-            <a:r>
-              <a:rPr lang="ko-KR" sz="1400" b="0">
-                <a:solidFill>
-                  <a:srgbClr val="0F172A"/>
-                </a:solidFill>
-                <a:latin typeface="Aptos"/>
-                <a:ea typeface="Malgun Gothic"/>
-              </a:rPr>
-              <a:t>work_mem     Execution Time     Batches     temp read     temp written</a:t>
-            </a:r>
-          </a:p>
-          <a:p>
-            <a:r>
-              <a:rPr lang="ko-KR" sz="1400" b="0">
-                <a:solidFill>
-                  <a:srgbClr val="0F172A"/>
-                </a:solidFill>
-                <a:latin typeface="Aptos"/>
-                <a:ea typeface="Malgun Gothic"/>
-              </a:rPr>
-              <a:t>4MB          4,295.640ms        5           26,516        46,759</a:t>
-            </a:r>
-          </a:p>
-          <a:p>
-            <a:r>
-              <a:rPr lang="ko-KR" sz="1400" b="0">
-                <a:solidFill>
-                  <a:srgbClr val="0F172A"/>
-                </a:solidFill>
-                <a:latin typeface="Aptos"/>
-                <a:ea typeface="Malgun Gothic"/>
-              </a:rPr>
-              <a:t>64MB         2,874.350ms        1           0             0</a:t>
-            </a:r>
-          </a:p>
-          <a:p>
-            <a:r>
-              <a:rPr lang="ko-KR" sz="1400" b="0">
-                <a:solidFill>
-                  <a:srgbClr val="0F172A"/>
-                </a:solidFill>
-                <a:latin typeface="Aptos"/>
-                <a:ea typeface="Malgun Gothic"/>
-              </a:rPr>
-              <a:t>128MB        2,645.038ms        1           0             0</a:t>
-            </a:r>
-          </a:p>
-          <a:p>
-            <a:r>
-              <a:rPr lang="ko-KR" sz="1400" b="0">
-                <a:solidFill>
-                  <a:srgbClr val="0F172A"/>
-                </a:solidFill>
-                <a:latin typeface="Aptos"/>
-                <a:ea typeface="Malgun Gothic"/>
-              </a:rPr>
-              <a:t>256MB        2,645.408ms        1           0             0</a:t>
-            </a:r>
-          </a:p>
-        </p:txBody>
-      </p:sp>
-      <p:sp>
-        <p:nvSpPr>
-          <p:cNvPr id="8" name="Shape 8"/>
-          <p:cNvSpPr txBox="1"/>
-          <p:nvPr/>
-        </p:nvSpPr>
-        <p:spPr>
-          <a:xfrm>
-            <a:off x="914400" y="4343400"/>
-            <a:ext cx="5120640" cy="1097280"/>
-          </a:xfrm>
-          <a:prstGeom prst="roundRect">
-            <a:avLst/>
-          </a:prstGeom>
-          <a:solidFill>
-            <a:srgbClr val="EFF6FF"/>
-          </a:solidFill>
-          <a:ln w="9525">
-            <a:solidFill>
-              <a:srgbClr val="BFDBFE"/>
+              <a:srgbClr val="E2E8F0"/>
             </a:solidFill>
           </a:ln>
         </p:spPr>
@@ -3496,14 +4132,14 @@
               <a:buChar char="•"/>
             </a:pPr>
             <a:r>
-              <a:rPr lang="ko-KR" sz="1500">
-                <a:solidFill>
-                  <a:srgbClr val="0F172A"/>
-                </a:solidFill>
-                <a:latin typeface="Aptos"/>
-                <a:ea typeface="Malgun Gothic"/>
-              </a:rPr>
-              <a:t>64MB부터 temp spill 제거</a:t>
+              <a:rPr lang="ko-KR" sz="1400">
+                <a:solidFill>
+                  <a:srgbClr val="0F172A"/>
+                </a:solidFill>
+                <a:latin typeface="Aptos"/>
+                <a:ea typeface="Malgun Gothic"/>
+              </a:rPr>
+              <a:t>기존: m.id, m.name, m.fee_rate 기준 GROUP BY</a:t>
             </a:r>
           </a:p>
           <a:p>
@@ -3511,14 +4147,14 @@
               <a:buChar char="•"/>
             </a:pPr>
             <a:r>
-              <a:rPr lang="ko-KR" sz="1500">
-                <a:solidFill>
-                  <a:srgbClr val="0F172A"/>
-                </a:solidFill>
-                <a:latin typeface="Aptos"/>
-                <a:ea typeface="Malgun Gothic"/>
-              </a:rPr>
-              <a:t>128MB와 256MB는 실행 시간 차이가 거의 없음</a:t>
+              <a:rPr lang="ko-KR" sz="1400">
+                <a:solidFill>
+                  <a:srgbClr val="0F172A"/>
+                </a:solidFill>
+                <a:latin typeface="Aptos"/>
+                <a:ea typeface="Malgun Gothic"/>
+              </a:rPr>
+              <a:t>개선: p.merchant_id 기준 선집계 + count(*)</a:t>
             </a:r>
           </a:p>
         </p:txBody>
@@ -3531,18 +4167,18 @@
         </p:nvSpPr>
         <p:spPr>
           <a:xfrm>
-            <a:off x="6355080" y="4343400"/>
-            <a:ext cx="4754880" cy="1097280"/>
+            <a:off x="6446520" y="2788920"/>
+            <a:ext cx="4800600" cy="1005840"/>
           </a:xfrm>
           <a:prstGeom prst="roundRect">
             <a:avLst/>
           </a:prstGeom>
           <a:solidFill>
-            <a:srgbClr val="EFF6FF"/>
-          </a:solidFill>
-          <a:ln w="9525">
-            <a:solidFill>
-              <a:srgbClr val="BFDBFE"/>
+            <a:srgbClr val="FFFFFF"/>
+          </a:solidFill>
+          <a:ln w="9525">
+            <a:solidFill>
+              <a:srgbClr val="E2E8F0"/>
             </a:solidFill>
           </a:ln>
         </p:spPr>
@@ -3554,14 +4190,14 @@
               <a:buChar char="•"/>
             </a:pPr>
             <a:r>
-              <a:rPr lang="ko-KR" sz="1500">
-                <a:solidFill>
-                  <a:srgbClr val="0F172A"/>
-                </a:solidFill>
-                <a:latin typeface="Aptos"/>
-                <a:ea typeface="Malgun Gothic"/>
-              </a:rPr>
-              <a:t>전역 변경은 동시성 메모리 위험</a:t>
+              <a:rPr lang="ko-KR" sz="1400">
+                <a:solidFill>
+                  <a:srgbClr val="0F172A"/>
+                </a:solidFill>
+                <a:latin typeface="Aptos"/>
+                <a:ea typeface="Malgun Gothic"/>
+              </a:rPr>
+              <a:t>핵심 집계는 payments 기준 금액 합계</a:t>
             </a:r>
           </a:p>
           <a:p>
@@ -3569,14 +4205,14 @@
               <a:buChar char="•"/>
             </a:pPr>
             <a:r>
-              <a:rPr lang="ko-KR" sz="1500">
-                <a:solidFill>
-                  <a:srgbClr val="0F172A"/>
-                </a:solidFill>
-                <a:latin typeface="Aptos"/>
-                <a:ea typeface="Malgun Gothic"/>
-              </a:rPr>
-              <a:t>세션 단위 실험으로 판단 근거 확보</a:t>
+              <a:rPr lang="ko-KR" sz="1400">
+                <a:solidFill>
+                  <a:srgbClr val="0F172A"/>
+                </a:solidFill>
+                <a:latin typeface="Aptos"/>
+                <a:ea typeface="Malgun Gothic"/>
+              </a:rPr>
+              <a:t>merchant 정보는 집계 후 조인해도 충분</a:t>
             </a:r>
           </a:p>
         </p:txBody>
@@ -3584,6 +4220,94 @@
       <p:sp>
         <p:nvSpPr>
           <p:cNvPr id="10" name="Shape 10"/>
+          <p:cNvSpPr txBox="1"/>
+          <p:nvPr/>
+        </p:nvSpPr>
+        <p:spPr>
+          <a:xfrm>
+            <a:off x="960120" y="4160520"/>
+            <a:ext cx="10287000" cy="1234440"/>
+          </a:xfrm>
+          <a:prstGeom prst="roundRect">
+            <a:avLst/>
+          </a:prstGeom>
+          <a:solidFill>
+            <a:srgbClr val="FFFFFF"/>
+          </a:solidFill>
+          <a:ln w="9525">
+            <a:solidFill>
+              <a:srgbClr val="CBD5E1"/>
+            </a:solidFill>
+          </a:ln>
+        </p:spPr>
+        <p:txBody>
+          <a:bodyPr wrap="square" anchor="t" lIns="91440" tIns="68580" rIns="91440" bIns="68580"/>
+          <a:lstStyle/>
+          <a:p>
+            <a:r>
+              <a:rPr lang="ko-KR" sz="1300" b="0">
+                <a:solidFill>
+                  <a:srgbClr val="0F172A"/>
+                </a:solidFill>
+                <a:latin typeface="Aptos"/>
+                <a:ea typeface="Malgun Gothic"/>
+              </a:rPr>
+              <a:t>항목                    개선 전       개선 후</a:t>
+            </a:r>
+          </a:p>
+          <a:p>
+            <a:r>
+              <a:rPr lang="ko-KR" sz="1300" b="0">
+                <a:solidFill>
+                  <a:srgbClr val="0F172A"/>
+                </a:solidFill>
+                <a:latin typeface="Aptos"/>
+                <a:ea typeface="Malgun Gothic"/>
+              </a:rPr>
+              <a:t>EXPLAIN                 3,855ms       3,274ms</a:t>
+            </a:r>
+          </a:p>
+          <a:p>
+            <a:r>
+              <a:rPr lang="ko-KR" sz="1300" b="0">
+                <a:solidFill>
+                  <a:srgbClr val="0F172A"/>
+                </a:solidFill>
+                <a:latin typeface="Aptos"/>
+                <a:ea typeface="Malgun Gothic"/>
+              </a:rPr>
+              <a:t>GROUP_BY_QUERY          5,026ms       4,796ms</a:t>
+            </a:r>
+          </a:p>
+          <a:p>
+            <a:r>
+              <a:rPr lang="ko-KR" sz="1300" b="0">
+                <a:solidFill>
+                  <a:srgbClr val="0F172A"/>
+                </a:solidFill>
+                <a:latin typeface="Aptos"/>
+                <a:ea typeface="Malgun Gothic"/>
+              </a:rPr>
+              <a:t>GROUP_BY_BULK_SAVE      4,596ms       4,149ms</a:t>
+            </a:r>
+          </a:p>
+          <a:p>
+            <a:r>
+              <a:rPr lang="ko-KR" sz="1300" b="0">
+                <a:solidFill>
+                  <a:srgbClr val="0F172A"/>
+                </a:solidFill>
+                <a:latin typeface="Aptos"/>
+                <a:ea typeface="Malgun Gothic"/>
+              </a:rPr>
+              <a:t>temp written            92,954        47,200</a:t>
+            </a:r>
+          </a:p>
+        </p:txBody>
+      </p:sp>
+      <p:sp>
+        <p:nvSpPr>
+          <p:cNvPr id="11" name="Shape 11"/>
           <p:cNvSpPr txBox="1"/>
           <p:nvPr/>
         </p:nvSpPr>
@@ -3612,14 +4336,14 @@
                 <a:latin typeface="Aptos"/>
                 <a:ea typeface="Malgun Gothic"/>
               </a:rPr>
-              <a:t>메모리 병목</a:t>
-            </a:r>
-          </a:p>
-        </p:txBody>
-      </p:sp>
-      <p:sp>
-        <p:nvSpPr>
-          <p:cNvPr id="11" name="Shape 11"/>
+              <a:t>쿼리 구조 개선</a:t>
+            </a:r>
+          </a:p>
+        </p:txBody>
+      </p:sp>
+      <p:sp>
+        <p:nvSpPr>
+          <p:cNvPr id="12" name="Shape 12"/>
           <p:cNvSpPr txBox="1"/>
           <p:nvPr/>
         </p:nvSpPr>
@@ -3789,7 +4513,7 @@
                 <a:latin typeface="Aptos"/>
                 <a:ea typeface="Malgun Gothic"/>
               </a:rPr>
-              <a:t>트러블슈팅 2: JPQL count(p)와 Index Only Scan</a:t>
+              <a:t>트러블슈팅 1: work_mem과 temp spill</a:t>
             </a:r>
           </a:p>
         </p:txBody>
@@ -3825,7 +4549,7 @@
                 <a:latin typeface="Aptos"/>
                 <a:ea typeface="Malgun Gothic"/>
               </a:rPr>
-              <a:t>Repository 코드가 아니라 실제 API SQL과 실행계획을 기준으로 판단</a:t>
+              <a:t>병목을 감으로 판단하지 않고 EXPLAIN과 temp 지표로 확인</a:t>
             </a:r>
           </a:p>
         </p:txBody>
@@ -3838,18 +4562,18 @@
         </p:nvSpPr>
         <p:spPr>
           <a:xfrm>
-            <a:off x="731520" y="1325880"/>
-            <a:ext cx="5074920" cy="1143000"/>
+            <a:off x="685800" y="1234440"/>
+            <a:ext cx="10881360" cy="411480"/>
           </a:xfrm>
           <a:prstGeom prst="roundRect">
             <a:avLst/>
           </a:prstGeom>
           <a:solidFill>
-            <a:srgbClr val="FEE2E2"/>
-          </a:solidFill>
-          <a:ln w="9525">
-            <a:solidFill>
-              <a:srgbClr val="FCA5A5"/>
+            <a:srgbClr val="FEF3C7"/>
+          </a:solidFill>
+          <a:ln w="9525">
+            <a:solidFill>
+              <a:srgbClr val="FDE68A"/>
             </a:solidFill>
           </a:ln>
         </p:spPr>
@@ -3865,31 +4589,7 @@
                 <a:latin typeface="Aptos"/>
                 <a:ea typeface="Malgun Gothic"/>
               </a:rPr>
-              <a:t>Before</a:t>
-            </a:r>
-          </a:p>
-          <a:p>
-            <a:r>
-              <a:rPr lang="ko-KR" sz="1600" b="1">
-                <a:solidFill>
-                  <a:srgbClr val="0F172A"/>
-                </a:solidFill>
-                <a:latin typeface="Aptos"/>
-                <a:ea typeface="Malgun Gothic"/>
-              </a:rPr>
-              <a:t>JPQL count(p) → SQL count(p.id)</a:t>
-            </a:r>
-          </a:p>
-          <a:p>
-            <a:r>
-              <a:rPr lang="ko-KR" sz="1600" b="1">
-                <a:solidFill>
-                  <a:srgbClr val="0F172A"/>
-                </a:solidFill>
-                <a:latin typeface="Aptos"/>
-                <a:ea typeface="Malgun Gothic"/>
-              </a:rPr>
-              <a:t>covering index에 id 없음 → heap 접근</a:t>
+              <a:t>HashAggregate temp spill: 기본 4MB에서는 batches=5, temp read/write 발생</a:t>
             </a:r>
           </a:p>
         </p:txBody>
@@ -3902,58 +4602,82 @@
         </p:nvSpPr>
         <p:spPr>
           <a:xfrm>
-            <a:off x="6355080" y="1325880"/>
-            <a:ext cx="5074920" cy="1143000"/>
+            <a:off x="731520" y="1874519"/>
+            <a:ext cx="10744200" cy="1965960"/>
           </a:xfrm>
           <a:prstGeom prst="roundRect">
             <a:avLst/>
           </a:prstGeom>
           <a:solidFill>
-            <a:srgbClr val="DCFCE7"/>
-          </a:solidFill>
-          <a:ln w="9525">
-            <a:solidFill>
-              <a:srgbClr val="86EFAC"/>
-            </a:solidFill>
-          </a:ln>
-        </p:spPr>
-        <p:txBody>
-          <a:bodyPr wrap="square" anchor="ctr" lIns="91440" tIns="68580" rIns="91440" bIns="68580"/>
-          <a:lstStyle/>
-          <a:p>
-            <a:r>
-              <a:rPr lang="ko-KR" sz="1600" b="1">
-                <a:solidFill>
-                  <a:srgbClr val="0F172A"/>
-                </a:solidFill>
-                <a:latin typeface="Aptos"/>
-                <a:ea typeface="Malgun Gothic"/>
-              </a:rPr>
-              <a:t>After</a:t>
-            </a:r>
-          </a:p>
-          <a:p>
-            <a:r>
-              <a:rPr lang="ko-KR" sz="1600" b="1">
-                <a:solidFill>
-                  <a:srgbClr val="0F172A"/>
-                </a:solidFill>
-                <a:latin typeface="Aptos"/>
-                <a:ea typeface="Malgun Gothic"/>
-              </a:rPr>
-              <a:t>native count(*) + interface projection</a:t>
-            </a:r>
-          </a:p>
-          <a:p>
-            <a:r>
-              <a:rPr lang="ko-KR" sz="1600" b="1">
-                <a:solidFill>
-                  <a:srgbClr val="0F172A"/>
-                </a:solidFill>
-                <a:latin typeface="Aptos"/>
-                <a:ea typeface="Malgun Gothic"/>
-              </a:rPr>
-              <a:t>Index Only Scan, Heap Fetches=0</a:t>
+            <a:srgbClr val="FFFFFF"/>
+          </a:solidFill>
+          <a:ln w="9525">
+            <a:solidFill>
+              <a:srgbClr val="CBD5E1"/>
+            </a:solidFill>
+          </a:ln>
+        </p:spPr>
+        <p:txBody>
+          <a:bodyPr wrap="square" anchor="t" lIns="91440" tIns="68580" rIns="91440" bIns="68580"/>
+          <a:lstStyle/>
+          <a:p>
+            <a:r>
+              <a:rPr lang="ko-KR" sz="1400" b="0">
+                <a:solidFill>
+                  <a:srgbClr val="0F172A"/>
+                </a:solidFill>
+                <a:latin typeface="Aptos"/>
+                <a:ea typeface="Malgun Gothic"/>
+              </a:rPr>
+              <a:t>work_mem     Execution Time     Batches     temp read     temp written</a:t>
+            </a:r>
+          </a:p>
+          <a:p>
+            <a:r>
+              <a:rPr lang="ko-KR" sz="1400" b="0">
+                <a:solidFill>
+                  <a:srgbClr val="0F172A"/>
+                </a:solidFill>
+                <a:latin typeface="Aptos"/>
+                <a:ea typeface="Malgun Gothic"/>
+              </a:rPr>
+              <a:t>4MB          4,295.640ms        5           26,516        46,759</a:t>
+            </a:r>
+          </a:p>
+          <a:p>
+            <a:r>
+              <a:rPr lang="ko-KR" sz="1400" b="0">
+                <a:solidFill>
+                  <a:srgbClr val="0F172A"/>
+                </a:solidFill>
+                <a:latin typeface="Aptos"/>
+                <a:ea typeface="Malgun Gothic"/>
+              </a:rPr>
+              <a:t>64MB         2,874.350ms        1           0             0</a:t>
+            </a:r>
+          </a:p>
+          <a:p>
+            <a:r>
+              <a:rPr lang="ko-KR" sz="1400" b="0">
+                <a:solidFill>
+                  <a:srgbClr val="0F172A"/>
+                </a:solidFill>
+                <a:latin typeface="Aptos"/>
+                <a:ea typeface="Malgun Gothic"/>
+              </a:rPr>
+              <a:t>128MB        2,645.038ms        1           0             0</a:t>
+            </a:r>
+          </a:p>
+          <a:p>
+            <a:r>
+              <a:rPr lang="ko-KR" sz="1400" b="0">
+                <a:solidFill>
+                  <a:srgbClr val="0F172A"/>
+                </a:solidFill>
+                <a:latin typeface="Aptos"/>
+                <a:ea typeface="Malgun Gothic"/>
+              </a:rPr>
+              <a:t>256MB        2,645.408ms        1           0             0</a:t>
             </a:r>
           </a:p>
         </p:txBody>
@@ -3966,18 +4690,18 @@
         </p:nvSpPr>
         <p:spPr>
           <a:xfrm>
-            <a:off x="868680" y="2971800"/>
-            <a:ext cx="4846320" cy="1508760"/>
+            <a:off x="914400" y="4343400"/>
+            <a:ext cx="5120640" cy="1097280"/>
           </a:xfrm>
           <a:prstGeom prst="roundRect">
             <a:avLst/>
           </a:prstGeom>
           <a:solidFill>
-            <a:srgbClr val="FFFFFF"/>
-          </a:solidFill>
-          <a:ln w="9525">
-            <a:solidFill>
-              <a:srgbClr val="E2E8F0"/>
+            <a:srgbClr val="EFF6FF"/>
+          </a:solidFill>
+          <a:ln w="9525">
+            <a:solidFill>
+              <a:srgbClr val="BFDBFE"/>
             </a:solidFill>
           </a:ln>
         </p:spPr>
@@ -3996,7 +4720,7 @@
                 <a:latin typeface="Aptos"/>
                 <a:ea typeface="Malgun Gothic"/>
               </a:rPr>
-              <a:t>수동 SQL은 count(*)라 Index Only Scan</a:t>
+              <a:t>64MB부터 temp spill 제거</a:t>
             </a:r>
           </a:p>
           <a:p>
@@ -4011,9 +4735,37 @@
                 <a:latin typeface="Aptos"/>
                 <a:ea typeface="Malgun Gothic"/>
               </a:rPr>
-              <a:t>API SQL은 count(p.id)로 heap 접근</a:t>
-            </a:r>
-          </a:p>
+              <a:t>128MB와 256MB는 실행 시간 차이가 거의 없음</a:t>
+            </a:r>
+          </a:p>
+        </p:txBody>
+      </p:sp>
+      <p:sp>
+        <p:nvSpPr>
+          <p:cNvPr id="9" name="Shape 9"/>
+          <p:cNvSpPr txBox="1"/>
+          <p:nvPr/>
+        </p:nvSpPr>
+        <p:spPr>
+          <a:xfrm>
+            <a:off x="6355080" y="4343400"/>
+            <a:ext cx="4754880" cy="1097280"/>
+          </a:xfrm>
+          <a:prstGeom prst="roundRect">
+            <a:avLst/>
+          </a:prstGeom>
+          <a:solidFill>
+            <a:srgbClr val="EFF6FF"/>
+          </a:solidFill>
+          <a:ln w="9525">
+            <a:solidFill>
+              <a:srgbClr val="BFDBFE"/>
+            </a:solidFill>
+          </a:ln>
+        </p:spPr>
+        <p:txBody>
+          <a:bodyPr wrap="square" anchor="t" lIns="91440" tIns="68580" rIns="91440" bIns="68580"/>
+          <a:lstStyle/>
           <a:p>
             <a:pPr marL="285750" indent="-171450">
               <a:buChar char="•"/>
@@ -4026,37 +4778,9 @@
                 <a:latin typeface="Aptos"/>
                 <a:ea typeface="Malgun Gothic"/>
               </a:rPr>
-              <a:t>수동 SQL과 API SQL 실행계획이 달랐음</a:t>
-            </a:r>
-          </a:p>
-        </p:txBody>
-      </p:sp>
-      <p:sp>
-        <p:nvSpPr>
-          <p:cNvPr id="9" name="Shape 9"/>
-          <p:cNvSpPr txBox="1"/>
-          <p:nvPr/>
-        </p:nvSpPr>
-        <p:spPr>
-          <a:xfrm>
-            <a:off x="6492240" y="2971800"/>
-            <a:ext cx="4709160" cy="1508760"/>
-          </a:xfrm>
-          <a:prstGeom prst="roundRect">
-            <a:avLst/>
-          </a:prstGeom>
-          <a:solidFill>
-            <a:srgbClr val="FFFFFF"/>
-          </a:solidFill>
-          <a:ln w="9525">
-            <a:solidFill>
-              <a:srgbClr val="E2E8F0"/>
-            </a:solidFill>
-          </a:ln>
-        </p:spPr>
-        <p:txBody>
-          <a:bodyPr wrap="square" anchor="t" lIns="91440" tIns="68580" rIns="91440" bIns="68580"/>
-          <a:lstStyle/>
+              <a:t>전역 변경은 동시성 메모리 위험</a:t>
+            </a:r>
+          </a:p>
           <a:p>
             <a:pPr marL="285750" indent="-171450">
               <a:buChar char="•"/>
@@ -4069,37 +4793,7 @@
                 <a:latin typeface="Aptos"/>
                 <a:ea typeface="Malgun Gothic"/>
               </a:rPr>
-              <a:t>집계 쿼리를 native query로 분리</a:t>
-            </a:r>
-          </a:p>
-          <a:p>
-            <a:pPr marL="285750" indent="-171450">
-              <a:buChar char="•"/>
-            </a:pPr>
-            <a:r>
-              <a:rPr lang="ko-KR" sz="1500">
-                <a:solidFill>
-                  <a:srgbClr val="0F172A"/>
-                </a:solidFill>
-                <a:latin typeface="Aptos"/>
-                <a:ea typeface="Malgun Gothic"/>
-              </a:rPr>
-              <a:t>count(*) 명시</a:t>
-            </a:r>
-          </a:p>
-          <a:p>
-            <a:pPr marL="285750" indent="-171450">
-              <a:buChar char="•"/>
-            </a:pPr>
-            <a:r>
-              <a:rPr lang="ko-KR" sz="1500">
-                <a:solidFill>
-                  <a:srgbClr val="0F172A"/>
-                </a:solidFill>
-                <a:latin typeface="Aptos"/>
-                <a:ea typeface="Malgun Gothic"/>
-              </a:rPr>
-              <a:t>API 경로에서도 Index Only Scan 확인</a:t>
+              <a:t>세션 단위 실험으로 판단 근거 확보</a:t>
             </a:r>
           </a:p>
         </p:txBody>
@@ -4107,46 +4801,6 @@
       <p:sp>
         <p:nvSpPr>
           <p:cNvPr id="10" name="Shape 10"/>
-          <p:cNvSpPr txBox="1"/>
-          <p:nvPr/>
-        </p:nvSpPr>
-        <p:spPr>
-          <a:xfrm>
-            <a:off x="1828800" y="4892040"/>
-            <a:ext cx="8595360" cy="502920"/>
-          </a:xfrm>
-          <a:prstGeom prst="roundRect">
-            <a:avLst/>
-          </a:prstGeom>
-          <a:solidFill>
-            <a:srgbClr val="E0F2FE"/>
-          </a:solidFill>
-          <a:ln w="9525">
-            <a:solidFill>
-              <a:srgbClr val="7DD3FC"/>
-            </a:solidFill>
-          </a:ln>
-        </p:spPr>
-        <p:txBody>
-          <a:bodyPr wrap="square" anchor="ctr" lIns="91440" tIns="68580" rIns="91440" bIns="68580"/>
-          <a:lstStyle/>
-          <a:p>
-            <a:r>
-              <a:rPr lang="ko-KR" sz="1700" b="1">
-                <a:solidFill>
-                  <a:srgbClr val="0F172A"/>
-                </a:solidFill>
-                <a:latin typeface="Aptos"/>
-                <a:ea typeface="Malgun Gothic"/>
-              </a:rPr>
-              <a:t>EXPLAIN 2,242.501ms → 74.988ms / DB 집계조회 수백 ms대로 개선</a:t>
-            </a:r>
-          </a:p>
-        </p:txBody>
-      </p:sp>
-      <p:sp>
-        <p:nvSpPr>
-          <p:cNvPr id="11" name="Shape 11"/>
           <p:cNvSpPr txBox="1"/>
           <p:nvPr/>
         </p:nvSpPr>
@@ -4175,14 +4829,14 @@
                 <a:latin typeface="Aptos"/>
                 <a:ea typeface="Malgun Gothic"/>
               </a:rPr>
-              <a:t>SQL 불일치</a:t>
-            </a:r>
-          </a:p>
-        </p:txBody>
-      </p:sp>
-      <p:sp>
-        <p:nvSpPr>
-          <p:cNvPr id="12" name="Shape 12"/>
+              <a:t>메모리 병목</a:t>
+            </a:r>
+          </a:p>
+        </p:txBody>
+      </p:sp>
+      <p:sp>
+        <p:nvSpPr>
+          <p:cNvPr id="11" name="Shape 11"/>
           <p:cNvSpPr txBox="1"/>
           <p:nvPr/>
         </p:nvSpPr>
@@ -4352,7 +5006,7 @@
                 <a:latin typeface="Aptos"/>
                 <a:ea typeface="Malgun Gothic"/>
               </a:rPr>
-              <a:t>트러블슈팅 3: saveAll과 IDENTITY 한계</a:t>
+              <a:t>트러블슈팅 2: JPQL count(p)와 Index Only Scan</a:t>
             </a:r>
           </a:p>
         </p:txBody>
@@ -4388,7 +5042,7 @@
                 <a:latin typeface="Aptos"/>
                 <a:ea typeface="Malgun Gothic"/>
               </a:rPr>
-              <a:t>saveAll이라는 메서드명보다 SQL 로그와 ID 생성 전략을 확인</a:t>
+              <a:t>Repository 코드가 아니라 실제 API SQL과 실행계획을 기준으로 판단</a:t>
             </a:r>
           </a:p>
         </p:txBody>
@@ -4401,8 +5055,8 @@
         </p:nvSpPr>
         <p:spPr>
           <a:xfrm>
-            <a:off x="685800" y="1234440"/>
-            <a:ext cx="5212080" cy="1143000"/>
+            <a:off x="731520" y="1325880"/>
+            <a:ext cx="5074920" cy="1143000"/>
           </a:xfrm>
           <a:prstGeom prst="roundRect">
             <a:avLst/>
@@ -4421,6 +5075,280 @@
           <a:lstStyle/>
           <a:p>
             <a:r>
+              <a:rPr lang="ko-KR" sz="1600" b="1">
+                <a:solidFill>
+                  <a:srgbClr val="0F172A"/>
+                </a:solidFill>
+                <a:latin typeface="Aptos"/>
+                <a:ea typeface="Malgun Gothic"/>
+              </a:rPr>
+              <a:t>Before</a:t>
+            </a:r>
+          </a:p>
+          <a:p>
+            <a:r>
+              <a:rPr lang="ko-KR" sz="1600" b="1">
+                <a:solidFill>
+                  <a:srgbClr val="0F172A"/>
+                </a:solidFill>
+                <a:latin typeface="Aptos"/>
+                <a:ea typeface="Malgun Gothic"/>
+              </a:rPr>
+              <a:t>JPQL count(p) → SQL count(p.id)</a:t>
+            </a:r>
+          </a:p>
+          <a:p>
+            <a:r>
+              <a:rPr lang="ko-KR" sz="1600" b="1">
+                <a:solidFill>
+                  <a:srgbClr val="0F172A"/>
+                </a:solidFill>
+                <a:latin typeface="Aptos"/>
+                <a:ea typeface="Malgun Gothic"/>
+              </a:rPr>
+              <a:t>covering index에 id 없음 → heap 접근</a:t>
+            </a:r>
+          </a:p>
+        </p:txBody>
+      </p:sp>
+      <p:sp>
+        <p:nvSpPr>
+          <p:cNvPr id="7" name="Shape 7"/>
+          <p:cNvSpPr txBox="1"/>
+          <p:nvPr/>
+        </p:nvSpPr>
+        <p:spPr>
+          <a:xfrm>
+            <a:off x="6355080" y="1325880"/>
+            <a:ext cx="5074920" cy="1143000"/>
+          </a:xfrm>
+          <a:prstGeom prst="roundRect">
+            <a:avLst/>
+          </a:prstGeom>
+          <a:solidFill>
+            <a:srgbClr val="DCFCE7"/>
+          </a:solidFill>
+          <a:ln w="9525">
+            <a:solidFill>
+              <a:srgbClr val="86EFAC"/>
+            </a:solidFill>
+          </a:ln>
+        </p:spPr>
+        <p:txBody>
+          <a:bodyPr wrap="square" anchor="ctr" lIns="91440" tIns="68580" rIns="91440" bIns="68580"/>
+          <a:lstStyle/>
+          <a:p>
+            <a:r>
+              <a:rPr lang="ko-KR" sz="1600" b="1">
+                <a:solidFill>
+                  <a:srgbClr val="0F172A"/>
+                </a:solidFill>
+                <a:latin typeface="Aptos"/>
+                <a:ea typeface="Malgun Gothic"/>
+              </a:rPr>
+              <a:t>After</a:t>
+            </a:r>
+          </a:p>
+          <a:p>
+            <a:r>
+              <a:rPr lang="ko-KR" sz="1600" b="1">
+                <a:solidFill>
+                  <a:srgbClr val="0F172A"/>
+                </a:solidFill>
+                <a:latin typeface="Aptos"/>
+                <a:ea typeface="Malgun Gothic"/>
+              </a:rPr>
+              <a:t>native count(*) + interface projection</a:t>
+            </a:r>
+          </a:p>
+          <a:p>
+            <a:r>
+              <a:rPr lang="ko-KR" sz="1600" b="1">
+                <a:solidFill>
+                  <a:srgbClr val="0F172A"/>
+                </a:solidFill>
+                <a:latin typeface="Aptos"/>
+                <a:ea typeface="Malgun Gothic"/>
+              </a:rPr>
+              <a:t>Index Only Scan, Heap Fetches=0</a:t>
+            </a:r>
+          </a:p>
+        </p:txBody>
+      </p:sp>
+      <p:sp>
+        <p:nvSpPr>
+          <p:cNvPr id="8" name="Shape 8"/>
+          <p:cNvSpPr txBox="1"/>
+          <p:nvPr/>
+        </p:nvSpPr>
+        <p:spPr>
+          <a:xfrm>
+            <a:off x="868680" y="2971800"/>
+            <a:ext cx="4846320" cy="1508760"/>
+          </a:xfrm>
+          <a:prstGeom prst="roundRect">
+            <a:avLst/>
+          </a:prstGeom>
+          <a:solidFill>
+            <a:srgbClr val="FFFFFF"/>
+          </a:solidFill>
+          <a:ln w="9525">
+            <a:solidFill>
+              <a:srgbClr val="E2E8F0"/>
+            </a:solidFill>
+          </a:ln>
+        </p:spPr>
+        <p:txBody>
+          <a:bodyPr wrap="square" anchor="t" lIns="91440" tIns="68580" rIns="91440" bIns="68580"/>
+          <a:lstStyle/>
+          <a:p>
+            <a:pPr marL="285750" indent="-171450">
+              <a:buChar char="•"/>
+            </a:pPr>
+            <a:r>
+              <a:rPr lang="ko-KR" sz="1500">
+                <a:solidFill>
+                  <a:srgbClr val="0F172A"/>
+                </a:solidFill>
+                <a:latin typeface="Aptos"/>
+                <a:ea typeface="Malgun Gothic"/>
+              </a:rPr>
+              <a:t>수동 SQL은 count(*)라 Index Only Scan</a:t>
+            </a:r>
+          </a:p>
+          <a:p>
+            <a:pPr marL="285750" indent="-171450">
+              <a:buChar char="•"/>
+            </a:pPr>
+            <a:r>
+              <a:rPr lang="ko-KR" sz="1500">
+                <a:solidFill>
+                  <a:srgbClr val="0F172A"/>
+                </a:solidFill>
+                <a:latin typeface="Aptos"/>
+                <a:ea typeface="Malgun Gothic"/>
+              </a:rPr>
+              <a:t>API SQL은 count(p.id)로 heap 접근</a:t>
+            </a:r>
+          </a:p>
+          <a:p>
+            <a:pPr marL="285750" indent="-171450">
+              <a:buChar char="•"/>
+            </a:pPr>
+            <a:r>
+              <a:rPr lang="ko-KR" sz="1500">
+                <a:solidFill>
+                  <a:srgbClr val="0F172A"/>
+                </a:solidFill>
+                <a:latin typeface="Aptos"/>
+                <a:ea typeface="Malgun Gothic"/>
+              </a:rPr>
+              <a:t>수동 SQL과 API SQL 실행계획이 달랐음</a:t>
+            </a:r>
+          </a:p>
+        </p:txBody>
+      </p:sp>
+      <p:sp>
+        <p:nvSpPr>
+          <p:cNvPr id="9" name="Shape 9"/>
+          <p:cNvSpPr txBox="1"/>
+          <p:nvPr/>
+        </p:nvSpPr>
+        <p:spPr>
+          <a:xfrm>
+            <a:off x="6492240" y="2971800"/>
+            <a:ext cx="4709160" cy="1508760"/>
+          </a:xfrm>
+          <a:prstGeom prst="roundRect">
+            <a:avLst/>
+          </a:prstGeom>
+          <a:solidFill>
+            <a:srgbClr val="FFFFFF"/>
+          </a:solidFill>
+          <a:ln w="9525">
+            <a:solidFill>
+              <a:srgbClr val="E2E8F0"/>
+            </a:solidFill>
+          </a:ln>
+        </p:spPr>
+        <p:txBody>
+          <a:bodyPr wrap="square" anchor="t" lIns="91440" tIns="68580" rIns="91440" bIns="68580"/>
+          <a:lstStyle/>
+          <a:p>
+            <a:pPr marL="285750" indent="-171450">
+              <a:buChar char="•"/>
+            </a:pPr>
+            <a:r>
+              <a:rPr lang="ko-KR" sz="1500">
+                <a:solidFill>
+                  <a:srgbClr val="0F172A"/>
+                </a:solidFill>
+                <a:latin typeface="Aptos"/>
+                <a:ea typeface="Malgun Gothic"/>
+              </a:rPr>
+              <a:t>집계 쿼리를 native query로 분리</a:t>
+            </a:r>
+          </a:p>
+          <a:p>
+            <a:pPr marL="285750" indent="-171450">
+              <a:buChar char="•"/>
+            </a:pPr>
+            <a:r>
+              <a:rPr lang="ko-KR" sz="1500">
+                <a:solidFill>
+                  <a:srgbClr val="0F172A"/>
+                </a:solidFill>
+                <a:latin typeface="Aptos"/>
+                <a:ea typeface="Malgun Gothic"/>
+              </a:rPr>
+              <a:t>count(*) 명시</a:t>
+            </a:r>
+          </a:p>
+          <a:p>
+            <a:pPr marL="285750" indent="-171450">
+              <a:buChar char="•"/>
+            </a:pPr>
+            <a:r>
+              <a:rPr lang="ko-KR" sz="1500">
+                <a:solidFill>
+                  <a:srgbClr val="0F172A"/>
+                </a:solidFill>
+                <a:latin typeface="Aptos"/>
+                <a:ea typeface="Malgun Gothic"/>
+              </a:rPr>
+              <a:t>API 경로에서도 Index Only Scan 확인</a:t>
+            </a:r>
+          </a:p>
+        </p:txBody>
+      </p:sp>
+      <p:sp>
+        <p:nvSpPr>
+          <p:cNvPr id="10" name="Shape 10"/>
+          <p:cNvSpPr txBox="1"/>
+          <p:nvPr/>
+        </p:nvSpPr>
+        <p:spPr>
+          <a:xfrm>
+            <a:off x="1828800" y="4892040"/>
+            <a:ext cx="8595360" cy="502920"/>
+          </a:xfrm>
+          <a:prstGeom prst="roundRect">
+            <a:avLst/>
+          </a:prstGeom>
+          <a:solidFill>
+            <a:srgbClr val="E0F2FE"/>
+          </a:solidFill>
+          <a:ln w="9525">
+            <a:solidFill>
+              <a:srgbClr val="7DD3FC"/>
+            </a:solidFill>
+          </a:ln>
+        </p:spPr>
+        <p:txBody>
+          <a:bodyPr wrap="square" anchor="ctr" lIns="91440" tIns="68580" rIns="91440" bIns="68580"/>
+          <a:lstStyle/>
+          <a:p>
+            <a:r>
               <a:rPr lang="ko-KR" sz="1700" b="1">
                 <a:solidFill>
                   <a:srgbClr val="0F172A"/>
@@ -4428,230 +5356,14 @@
                 <a:latin typeface="Aptos"/>
                 <a:ea typeface="Malgun Gothic"/>
               </a:rPr>
-              <a:t>IDENTITY</a:t>
-            </a:r>
-          </a:p>
-          <a:p>
-            <a:r>
-              <a:rPr lang="ko-KR" sz="1700" b="1">
-                <a:solidFill>
-                  <a:srgbClr val="0F172A"/>
-                </a:solidFill>
-                <a:latin typeface="Aptos"/>
-                <a:ea typeface="Malgun Gothic"/>
-              </a:rPr>
-              <a:t>insert 후 DB generated id 조회</a:t>
-            </a:r>
-          </a:p>
-          <a:p>
-            <a:r>
-              <a:rPr lang="ko-KR" sz="1700" b="1">
-                <a:solidFill>
-                  <a:srgbClr val="0F172A"/>
-                </a:solidFill>
-                <a:latin typeface="Aptos"/>
-                <a:ea typeface="Malgun Gothic"/>
-              </a:rPr>
-              <a:t>batch insert에 불리</a:t>
-            </a:r>
-          </a:p>
-        </p:txBody>
-      </p:sp>
-      <p:sp>
-        <p:nvSpPr>
-          <p:cNvPr id="7" name="Shape 7"/>
-          <p:cNvSpPr txBox="1"/>
-          <p:nvPr/>
-        </p:nvSpPr>
-        <p:spPr>
-          <a:xfrm>
-            <a:off x="6263640" y="1234440"/>
-            <a:ext cx="5212080" cy="1143000"/>
-          </a:xfrm>
-          <a:prstGeom prst="roundRect">
-            <a:avLst/>
-          </a:prstGeom>
-          <a:solidFill>
-            <a:srgbClr val="DCFCE7"/>
-          </a:solidFill>
-          <a:ln w="9525">
-            <a:solidFill>
-              <a:srgbClr val="86EFAC"/>
-            </a:solidFill>
-          </a:ln>
-        </p:spPr>
-        <p:txBody>
-          <a:bodyPr wrap="square" anchor="ctr" lIns="91440" tIns="68580" rIns="91440" bIns="68580"/>
-          <a:lstStyle/>
-          <a:p>
-            <a:r>
-              <a:rPr lang="ko-KR" sz="1700" b="1">
-                <a:solidFill>
-                  <a:srgbClr val="0F172A"/>
-                </a:solidFill>
-                <a:latin typeface="Aptos"/>
-                <a:ea typeface="Malgun Gothic"/>
-              </a:rPr>
-              <a:t>SEQUENCE</a:t>
-            </a:r>
-          </a:p>
-          <a:p>
-            <a:r>
-              <a:rPr lang="ko-KR" sz="1700" b="1">
-                <a:solidFill>
-                  <a:srgbClr val="0F172A"/>
-                </a:solidFill>
-                <a:latin typeface="Aptos"/>
-                <a:ea typeface="Malgun Gothic"/>
-              </a:rPr>
-              <a:t>insert 전 sequence로 id 확보</a:t>
-            </a:r>
-          </a:p>
-          <a:p>
-            <a:r>
-              <a:rPr lang="ko-KR" sz="1700" b="1">
-                <a:solidFill>
-                  <a:srgbClr val="0F172A"/>
-                </a:solidFill>
-                <a:latin typeface="Aptos"/>
-                <a:ea typeface="Malgun Gothic"/>
-              </a:rPr>
-              <a:t>batch 처리에 유리</a:t>
-            </a:r>
-          </a:p>
-        </p:txBody>
-      </p:sp>
-      <p:sp>
-        <p:nvSpPr>
-          <p:cNvPr id="8" name="Shape 8"/>
-          <p:cNvSpPr txBox="1"/>
-          <p:nvPr/>
-        </p:nvSpPr>
-        <p:spPr>
-          <a:xfrm>
-            <a:off x="777240" y="2743200"/>
-            <a:ext cx="10652760" cy="1920240"/>
-          </a:xfrm>
-          <a:prstGeom prst="roundRect">
-            <a:avLst/>
-          </a:prstGeom>
-          <a:solidFill>
-            <a:srgbClr val="FFFFFF"/>
-          </a:solidFill>
-          <a:ln w="9525">
-            <a:solidFill>
-              <a:srgbClr val="CBD5E1"/>
-            </a:solidFill>
-          </a:ln>
-        </p:spPr>
-        <p:txBody>
-          <a:bodyPr wrap="square" anchor="t" lIns="91440" tIns="68580" rIns="91440" bIns="68580"/>
-          <a:lstStyle/>
-          <a:p>
-            <a:r>
-              <a:rPr lang="ko-KR" sz="1300" b="0">
-                <a:solidFill>
-                  <a:srgbClr val="0F172A"/>
-                </a:solidFill>
-                <a:latin typeface="Aptos"/>
-                <a:ea typeface="Malgun Gothic"/>
-              </a:rPr>
-              <a:t>전략                    ID 전략       저장 평균       API 전체 평균</a:t>
-            </a:r>
-          </a:p>
-          <a:p>
-            <a:r>
-              <a:rPr lang="ko-KR" sz="1300" b="0">
-                <a:solidFill>
-                  <a:srgbClr val="0F172A"/>
-                </a:solidFill>
-                <a:latin typeface="Aptos"/>
-                <a:ea typeface="Malgun Gothic"/>
-              </a:rPr>
-              <a:t>GROUP_BY_QUERY          IDENTITY      1,105.225ms     1,490.271ms</a:t>
-            </a:r>
-          </a:p>
-          <a:p>
-            <a:r>
-              <a:rPr lang="ko-KR" sz="1300" b="0">
-                <a:solidFill>
-                  <a:srgbClr val="0F172A"/>
-                </a:solidFill>
-                <a:latin typeface="Aptos"/>
-                <a:ea typeface="Malgun Gothic"/>
-              </a:rPr>
-              <a:t>GROUP_BY_BULK_SAVE      IDENTITY      975.471ms       1,289.364ms</a:t>
-            </a:r>
-          </a:p>
-          <a:p>
-            <a:r>
-              <a:rPr lang="ko-KR" sz="1300" b="0">
-                <a:solidFill>
-                  <a:srgbClr val="0F172A"/>
-                </a:solidFill>
-                <a:latin typeface="Aptos"/>
-                <a:ea typeface="Malgun Gothic"/>
-              </a:rPr>
-              <a:t>GROUP_BY_QUERY          SEQUENCE      101.945ms       755.662ms</a:t>
-            </a:r>
-          </a:p>
-          <a:p>
-            <a:r>
-              <a:rPr lang="ko-KR" sz="1300" b="0">
-                <a:solidFill>
-                  <a:srgbClr val="0F172A"/>
-                </a:solidFill>
-                <a:latin typeface="Aptos"/>
-                <a:ea typeface="Malgun Gothic"/>
-              </a:rPr>
-              <a:t>GROUP_BY_BULK_SAVE      SEQUENCE      40.449ms        696.352ms</a:t>
-            </a:r>
-          </a:p>
-        </p:txBody>
-      </p:sp>
-      <p:sp>
-        <p:nvSpPr>
-          <p:cNvPr id="9" name="Shape 9"/>
-          <p:cNvSpPr txBox="1"/>
-          <p:nvPr/>
-        </p:nvSpPr>
-        <p:spPr>
-          <a:xfrm>
-            <a:off x="914400" y="5166360"/>
-            <a:ext cx="10241280" cy="411480"/>
-          </a:xfrm>
-          <a:prstGeom prst="roundRect">
-            <a:avLst/>
-          </a:prstGeom>
-          <a:solidFill>
-            <a:srgbClr val="E0F2FE"/>
-          </a:solidFill>
-          <a:ln w="9525">
-            <a:solidFill>
-              <a:srgbClr val="7DD3FC"/>
-            </a:solidFill>
-          </a:ln>
-        </p:spPr>
-        <p:txBody>
-          <a:bodyPr wrap="square" anchor="ctr" lIns="91440" tIns="68580" rIns="91440" bIns="68580"/>
-          <a:lstStyle/>
-          <a:p>
-            <a:r>
-              <a:rPr lang="ko-KR" sz="1500" b="1">
-                <a:solidFill>
-                  <a:srgbClr val="0F172A"/>
-                </a:solidFill>
-                <a:latin typeface="Aptos"/>
-                <a:ea typeface="Malgun Gothic"/>
-              </a:rPr>
-              <a:t>SQL 로그: saveAll 이후에도 개별 insert 반복 → Hibernate batch 설정과 ID 전략을 분리 실험</a:t>
-            </a:r>
-          </a:p>
-        </p:txBody>
-      </p:sp>
-      <p:sp>
-        <p:nvSpPr>
-          <p:cNvPr id="10" name="Shape 10"/>
+              <a:t>EXPLAIN 2,242.501ms → 74.988ms / DB 집계조회 수백 ms대로 개선</a:t>
+            </a:r>
+          </a:p>
+        </p:txBody>
+      </p:sp>
+      <p:sp>
+        <p:nvSpPr>
+          <p:cNvPr id="11" name="Shape 11"/>
           <p:cNvSpPr txBox="1"/>
           <p:nvPr/>
         </p:nvSpPr>
@@ -4680,14 +5392,14 @@
                 <a:latin typeface="Aptos"/>
                 <a:ea typeface="Malgun Gothic"/>
               </a:rPr>
-              <a:t>저장 병목</a:t>
-            </a:r>
-          </a:p>
-        </p:txBody>
-      </p:sp>
-      <p:sp>
-        <p:nvSpPr>
-          <p:cNvPr id="11" name="Shape 11"/>
+              <a:t>SQL 불일치</a:t>
+            </a:r>
+          </a:p>
+        </p:txBody>
+      </p:sp>
+      <p:sp>
+        <p:nvSpPr>
+          <p:cNvPr id="12" name="Shape 12"/>
           <p:cNvSpPr txBox="1"/>
           <p:nvPr/>
         </p:nvSpPr>
@@ -4857,7 +5569,7 @@
                 <a:latin typeface="Aptos"/>
                 <a:ea typeface="Malgun Gothic"/>
               </a:rPr>
-              <a:t>최종 성능 결과와 배운 점</a:t>
+              <a:t>트러블슈팅 3: saveAll과 IDENTITY 한계</a:t>
             </a:r>
           </a:p>
         </p:txBody>
@@ -4893,7 +5605,7 @@
                 <a:latin typeface="Aptos"/>
                 <a:ea typeface="Malgun Gothic"/>
               </a:rPr>
-              <a:t>성능 개선 후에도 처리 건수, Settlement 건수, 총액 동일성을 확인</a:t>
+              <a:t>saveAll이라는 메서드명보다 SQL 로그와 ID 생성 전략을 확인</a:t>
             </a:r>
           </a:p>
         </p:txBody>
@@ -4906,18 +5618,234 @@
         </p:nvSpPr>
         <p:spPr>
           <a:xfrm>
-            <a:off x="594360" y="1143000"/>
-            <a:ext cx="3566160" cy="1417320"/>
+            <a:off x="685800" y="1234440"/>
+            <a:ext cx="5212080" cy="1143000"/>
           </a:xfrm>
           <a:prstGeom prst="roundRect">
             <a:avLst/>
           </a:prstGeom>
           <a:solidFill>
+            <a:srgbClr val="FEE2E2"/>
+          </a:solidFill>
+          <a:ln w="9525">
+            <a:solidFill>
+              <a:srgbClr val="FCA5A5"/>
+            </a:solidFill>
+          </a:ln>
+        </p:spPr>
+        <p:txBody>
+          <a:bodyPr wrap="square" anchor="ctr" lIns="91440" tIns="68580" rIns="91440" bIns="68580"/>
+          <a:lstStyle/>
+          <a:p>
+            <a:r>
+              <a:rPr lang="ko-KR" sz="1700" b="1">
+                <a:solidFill>
+                  <a:srgbClr val="0F172A"/>
+                </a:solidFill>
+                <a:latin typeface="Aptos"/>
+                <a:ea typeface="Malgun Gothic"/>
+              </a:rPr>
+              <a:t>IDENTITY</a:t>
+            </a:r>
+          </a:p>
+          <a:p>
+            <a:r>
+              <a:rPr lang="ko-KR" sz="1700" b="1">
+                <a:solidFill>
+                  <a:srgbClr val="0F172A"/>
+                </a:solidFill>
+                <a:latin typeface="Aptos"/>
+                <a:ea typeface="Malgun Gothic"/>
+              </a:rPr>
+              <a:t>insert 후 DB generated id 조회</a:t>
+            </a:r>
+          </a:p>
+          <a:p>
+            <a:r>
+              <a:rPr lang="ko-KR" sz="1700" b="1">
+                <a:solidFill>
+                  <a:srgbClr val="0F172A"/>
+                </a:solidFill>
+                <a:latin typeface="Aptos"/>
+                <a:ea typeface="Malgun Gothic"/>
+              </a:rPr>
+              <a:t>batch insert에 불리</a:t>
+            </a:r>
+          </a:p>
+        </p:txBody>
+      </p:sp>
+      <p:sp>
+        <p:nvSpPr>
+          <p:cNvPr id="7" name="Shape 7"/>
+          <p:cNvSpPr txBox="1"/>
+          <p:nvPr/>
+        </p:nvSpPr>
+        <p:spPr>
+          <a:xfrm>
+            <a:off x="6263640" y="1234440"/>
+            <a:ext cx="5212080" cy="1143000"/>
+          </a:xfrm>
+          <a:prstGeom prst="roundRect">
+            <a:avLst/>
+          </a:prstGeom>
+          <a:solidFill>
+            <a:srgbClr val="DCFCE7"/>
+          </a:solidFill>
+          <a:ln w="9525">
+            <a:solidFill>
+              <a:srgbClr val="86EFAC"/>
+            </a:solidFill>
+          </a:ln>
+        </p:spPr>
+        <p:txBody>
+          <a:bodyPr wrap="square" anchor="ctr" lIns="91440" tIns="68580" rIns="91440" bIns="68580"/>
+          <a:lstStyle/>
+          <a:p>
+            <a:r>
+              <a:rPr lang="ko-KR" sz="1700" b="1">
+                <a:solidFill>
+                  <a:srgbClr val="0F172A"/>
+                </a:solidFill>
+                <a:latin typeface="Aptos"/>
+                <a:ea typeface="Malgun Gothic"/>
+              </a:rPr>
+              <a:t>SEQUENCE</a:t>
+            </a:r>
+          </a:p>
+          <a:p>
+            <a:r>
+              <a:rPr lang="ko-KR" sz="1700" b="1">
+                <a:solidFill>
+                  <a:srgbClr val="0F172A"/>
+                </a:solidFill>
+                <a:latin typeface="Aptos"/>
+                <a:ea typeface="Malgun Gothic"/>
+              </a:rPr>
+              <a:t>insert 전 sequence로 id 확보</a:t>
+            </a:r>
+          </a:p>
+          <a:p>
+            <a:r>
+              <a:rPr lang="ko-KR" sz="1700" b="1">
+                <a:solidFill>
+                  <a:srgbClr val="0F172A"/>
+                </a:solidFill>
+                <a:latin typeface="Aptos"/>
+                <a:ea typeface="Malgun Gothic"/>
+              </a:rPr>
+              <a:t>batch 처리에 유리</a:t>
+            </a:r>
+          </a:p>
+        </p:txBody>
+      </p:sp>
+      <p:sp>
+        <p:nvSpPr>
+          <p:cNvPr id="8" name="Shape 8"/>
+          <p:cNvSpPr txBox="1"/>
+          <p:nvPr/>
+        </p:nvSpPr>
+        <p:spPr>
+          <a:xfrm>
+            <a:off x="777240" y="2743200"/>
+            <a:ext cx="10652760" cy="1920240"/>
+          </a:xfrm>
+          <a:prstGeom prst="roundRect">
+            <a:avLst/>
+          </a:prstGeom>
+          <a:solidFill>
             <a:srgbClr val="FFFFFF"/>
           </a:solidFill>
           <a:ln w="9525">
             <a:solidFill>
-              <a:srgbClr val="BFDBFE"/>
+              <a:srgbClr val="CBD5E1"/>
+            </a:solidFill>
+          </a:ln>
+        </p:spPr>
+        <p:txBody>
+          <a:bodyPr wrap="square" anchor="t" lIns="91440" tIns="68580" rIns="91440" bIns="68580"/>
+          <a:lstStyle/>
+          <a:p>
+            <a:r>
+              <a:rPr lang="ko-KR" sz="1300" b="0">
+                <a:solidFill>
+                  <a:srgbClr val="0F172A"/>
+                </a:solidFill>
+                <a:latin typeface="Aptos"/>
+                <a:ea typeface="Malgun Gothic"/>
+              </a:rPr>
+              <a:t>전략                    ID 전략       저장 평균       API 전체 평균</a:t>
+            </a:r>
+          </a:p>
+          <a:p>
+            <a:r>
+              <a:rPr lang="ko-KR" sz="1300" b="0">
+                <a:solidFill>
+                  <a:srgbClr val="0F172A"/>
+                </a:solidFill>
+                <a:latin typeface="Aptos"/>
+                <a:ea typeface="Malgun Gothic"/>
+              </a:rPr>
+              <a:t>GROUP_BY_QUERY          IDENTITY      1,105.225ms     1,490.271ms</a:t>
+            </a:r>
+          </a:p>
+          <a:p>
+            <a:r>
+              <a:rPr lang="ko-KR" sz="1300" b="0">
+                <a:solidFill>
+                  <a:srgbClr val="0F172A"/>
+                </a:solidFill>
+                <a:latin typeface="Aptos"/>
+                <a:ea typeface="Malgun Gothic"/>
+              </a:rPr>
+              <a:t>GROUP_BY_BULK_SAVE      IDENTITY      975.471ms       1,289.364ms</a:t>
+            </a:r>
+          </a:p>
+          <a:p>
+            <a:r>
+              <a:rPr lang="ko-KR" sz="1300" b="0">
+                <a:solidFill>
+                  <a:srgbClr val="0F172A"/>
+                </a:solidFill>
+                <a:latin typeface="Aptos"/>
+                <a:ea typeface="Malgun Gothic"/>
+              </a:rPr>
+              <a:t>GROUP_BY_QUERY          SEQUENCE      101.945ms       755.662ms</a:t>
+            </a:r>
+          </a:p>
+          <a:p>
+            <a:r>
+              <a:rPr lang="ko-KR" sz="1300" b="0">
+                <a:solidFill>
+                  <a:srgbClr val="0F172A"/>
+                </a:solidFill>
+                <a:latin typeface="Aptos"/>
+                <a:ea typeface="Malgun Gothic"/>
+              </a:rPr>
+              <a:t>GROUP_BY_BULK_SAVE      SEQUENCE      40.449ms        696.352ms</a:t>
+            </a:r>
+          </a:p>
+        </p:txBody>
+      </p:sp>
+      <p:sp>
+        <p:nvSpPr>
+          <p:cNvPr id="9" name="Shape 9"/>
+          <p:cNvSpPr txBox="1"/>
+          <p:nvPr/>
+        </p:nvSpPr>
+        <p:spPr>
+          <a:xfrm>
+            <a:off x="914400" y="5166360"/>
+            <a:ext cx="10241280" cy="411480"/>
+          </a:xfrm>
+          <a:prstGeom prst="roundRect">
+            <a:avLst/>
+          </a:prstGeom>
+          <a:solidFill>
+            <a:srgbClr val="E0F2FE"/>
+          </a:solidFill>
+          <a:ln w="9525">
+            <a:solidFill>
+              <a:srgbClr val="7DD3FC"/>
             </a:solidFill>
           </a:ln>
         </p:spPr>
@@ -4933,256 +5861,7 @@
                 <a:latin typeface="Aptos"/>
                 <a:ea typeface="Malgun Gothic"/>
               </a:rPr>
-              <a:t>100만 건</a:t>
-            </a:r>
-          </a:p>
-          <a:p>
-            <a:r>
-              <a:rPr lang="ko-KR" sz="1500" b="1">
-                <a:solidFill>
-                  <a:srgbClr val="0F172A"/>
-                </a:solidFill>
-                <a:latin typeface="Aptos"/>
-                <a:ea typeface="Malgun Gothic"/>
-              </a:rPr>
-              <a:t>BASIC_LOOP 8,253ms</a:t>
-            </a:r>
-          </a:p>
-          <a:p>
-            <a:r>
-              <a:rPr lang="ko-KR" sz="1500" b="1">
-                <a:solidFill>
-                  <a:srgbClr val="0F172A"/>
-                </a:solidFill>
-                <a:latin typeface="Aptos"/>
-                <a:ea typeface="Malgun Gothic"/>
-              </a:rPr>
-              <a:t>GROUP_BY_QUERY 899ms</a:t>
-            </a:r>
-          </a:p>
-          <a:p>
-            <a:r>
-              <a:rPr lang="ko-KR" sz="1500" b="1">
-                <a:solidFill>
-                  <a:srgbClr val="0F172A"/>
-                </a:solidFill>
-                <a:latin typeface="Aptos"/>
-                <a:ea typeface="Malgun Gothic"/>
-              </a:rPr>
-              <a:t>GROUP_BY_BULK_SAVE 798ms</a:t>
-            </a:r>
-          </a:p>
-        </p:txBody>
-      </p:sp>
-      <p:sp>
-        <p:nvSpPr>
-          <p:cNvPr id="7" name="Shape 7"/>
-          <p:cNvSpPr txBox="1"/>
-          <p:nvPr/>
-        </p:nvSpPr>
-        <p:spPr>
-          <a:xfrm>
-            <a:off x="4343400" y="1143000"/>
-            <a:ext cx="3566160" cy="1417320"/>
-          </a:xfrm>
-          <a:prstGeom prst="roundRect">
-            <a:avLst/>
-          </a:prstGeom>
-          <a:solidFill>
-            <a:srgbClr val="FFFFFF"/>
-          </a:solidFill>
-          <a:ln w="9525">
-            <a:solidFill>
-              <a:srgbClr val="BFDBFE"/>
-            </a:solidFill>
-          </a:ln>
-        </p:spPr>
-        <p:txBody>
-          <a:bodyPr wrap="square" anchor="ctr" lIns="91440" tIns="68580" rIns="91440" bIns="68580"/>
-          <a:lstStyle/>
-          <a:p>
-            <a:r>
-              <a:rPr lang="ko-KR" sz="1300" b="1">
-                <a:solidFill>
-                  <a:srgbClr val="0F172A"/>
-                </a:solidFill>
-                <a:latin typeface="Aptos"/>
-                <a:ea typeface="Malgun Gothic"/>
-              </a:rPr>
-              <a:t>날짜 분산 1000만 건</a:t>
-            </a:r>
-          </a:p>
-          <a:p>
-            <a:r>
-              <a:rPr lang="ko-KR" sz="1300" b="1">
-                <a:solidFill>
-                  <a:srgbClr val="0F172A"/>
-                </a:solidFill>
-                <a:latin typeface="Aptos"/>
-                <a:ea typeface="Malgun Gothic"/>
-              </a:rPr>
-              <a:t>EXPLAIN 2,242.501ms → 74.988ms</a:t>
-            </a:r>
-          </a:p>
-          <a:p>
-            <a:r>
-              <a:rPr lang="ko-KR" sz="1300" b="1">
-                <a:solidFill>
-                  <a:srgbClr val="0F172A"/>
-                </a:solidFill>
-                <a:latin typeface="Aptos"/>
-                <a:ea typeface="Malgun Gothic"/>
-              </a:rPr>
-              <a:t>API GQ 3,021.333ms → 1,627.667ms</a:t>
-            </a:r>
-          </a:p>
-          <a:p>
-            <a:r>
-              <a:rPr lang="ko-KR" sz="1300" b="1">
-                <a:solidFill>
-                  <a:srgbClr val="0F172A"/>
-                </a:solidFill>
-                <a:latin typeface="Aptos"/>
-                <a:ea typeface="Malgun Gothic"/>
-              </a:rPr>
-              <a:t>API GBS 2,478.333ms → 2,058.000ms</a:t>
-            </a:r>
-          </a:p>
-        </p:txBody>
-      </p:sp>
-      <p:sp>
-        <p:nvSpPr>
-          <p:cNvPr id="8" name="Shape 8"/>
-          <p:cNvSpPr txBox="1"/>
-          <p:nvPr/>
-        </p:nvSpPr>
-        <p:spPr>
-          <a:xfrm>
-            <a:off x="8092440" y="1143000"/>
-            <a:ext cx="3566160" cy="1417320"/>
-          </a:xfrm>
-          <a:prstGeom prst="roundRect">
-            <a:avLst/>
-          </a:prstGeom>
-          <a:solidFill>
-            <a:srgbClr val="FFFFFF"/>
-          </a:solidFill>
-          <a:ln w="9525">
-            <a:solidFill>
-              <a:srgbClr val="BFDBFE"/>
-            </a:solidFill>
-          </a:ln>
-        </p:spPr>
-        <p:txBody>
-          <a:bodyPr wrap="square" anchor="ctr" lIns="91440" tIns="68580" rIns="91440" bIns="68580"/>
-          <a:lstStyle/>
-          <a:p>
-            <a:r>
-              <a:rPr lang="ko-KR" sz="1500" b="1">
-                <a:solidFill>
-                  <a:srgbClr val="0F172A"/>
-                </a:solidFill>
-                <a:latin typeface="Aptos"/>
-                <a:ea typeface="Malgun Gothic"/>
-              </a:rPr>
-              <a:t>SEQUENCE 변경 후</a:t>
-            </a:r>
-          </a:p>
-          <a:p>
-            <a:r>
-              <a:rPr lang="ko-KR" sz="1500" b="1">
-                <a:solidFill>
-                  <a:srgbClr val="0F172A"/>
-                </a:solidFill>
-                <a:latin typeface="Aptos"/>
-                <a:ea typeface="Malgun Gothic"/>
-              </a:rPr>
-              <a:t>GROUP_BY_QUERY 755.662ms</a:t>
-            </a:r>
-          </a:p>
-          <a:p>
-            <a:r>
-              <a:rPr lang="ko-KR" sz="1500" b="1">
-                <a:solidFill>
-                  <a:srgbClr val="0F172A"/>
-                </a:solidFill>
-                <a:latin typeface="Aptos"/>
-                <a:ea typeface="Malgun Gothic"/>
-              </a:rPr>
-              <a:t>GROUP_BY_BULK_SAVE 696.352ms</a:t>
-            </a:r>
-          </a:p>
-        </p:txBody>
-      </p:sp>
-      <p:sp>
-        <p:nvSpPr>
-          <p:cNvPr id="9" name="Shape 9"/>
-          <p:cNvSpPr txBox="1"/>
-          <p:nvPr/>
-        </p:nvSpPr>
-        <p:spPr>
-          <a:xfrm>
-            <a:off x="777240" y="3108960"/>
-            <a:ext cx="5212080" cy="1691640"/>
-          </a:xfrm>
-          <a:prstGeom prst="roundRect">
-            <a:avLst/>
-          </a:prstGeom>
-          <a:solidFill>
-            <a:srgbClr val="EFF6FF"/>
-          </a:solidFill>
-          <a:ln w="9525">
-            <a:solidFill>
-              <a:srgbClr val="BFDBFE"/>
-            </a:solidFill>
-          </a:ln>
-        </p:spPr>
-        <p:txBody>
-          <a:bodyPr wrap="square" anchor="t" lIns="91440" tIns="68580" rIns="91440" bIns="68580"/>
-          <a:lstStyle/>
-          <a:p>
-            <a:pPr marL="285750" indent="-171450">
-              <a:buChar char="•"/>
-            </a:pPr>
-            <a:r>
-              <a:rPr lang="ko-KR" sz="1500">
-                <a:solidFill>
-                  <a:srgbClr val="0F172A"/>
-                </a:solidFill>
-                <a:latin typeface="Aptos"/>
-                <a:ea typeface="Malgun Gothic"/>
-              </a:rPr>
-              <a:t>EXPLAIN, SQL 로그, 구간별 측정으로 판단</a:t>
-            </a:r>
-          </a:p>
-          <a:p>
-            <a:pPr marL="285750" indent="-171450">
-              <a:buChar char="•"/>
-            </a:pPr>
-            <a:r>
-              <a:rPr lang="ko-KR" sz="1500">
-                <a:solidFill>
-                  <a:srgbClr val="0F172A"/>
-                </a:solidFill>
-                <a:latin typeface="Aptos"/>
-                <a:ea typeface="Malgun Gothic"/>
-              </a:rPr>
-              <a:t>processedCount=322,581 확인</a:t>
-            </a:r>
-          </a:p>
-          <a:p>
-            <a:pPr marL="285750" indent="-171450">
-              <a:buChar char="•"/>
-            </a:pPr>
-            <a:r>
-              <a:rPr lang="ko-KR" sz="1500">
-                <a:solidFill>
-                  <a:srgbClr val="0F172A"/>
-                </a:solidFill>
-                <a:latin typeface="Aptos"/>
-                <a:ea typeface="Malgun Gothic"/>
-              </a:rPr>
-              <a:t>Settlement 10,000건 확인</a:t>
+              <a:t>SQL 로그: saveAll 이후에도 개별 insert 반복 → Hibernate batch 설정과 ID 전략을 분리 실험</a:t>
             </a:r>
           </a:p>
         </p:txBody>
@@ -5190,79 +5869,6 @@
       <p:sp>
         <p:nvSpPr>
           <p:cNvPr id="10" name="Shape 10"/>
-          <p:cNvSpPr txBox="1"/>
-          <p:nvPr/>
-        </p:nvSpPr>
-        <p:spPr>
-          <a:xfrm>
-            <a:off x="6263640" y="3108960"/>
-            <a:ext cx="5074920" cy="1691640"/>
-          </a:xfrm>
-          <a:prstGeom prst="roundRect">
-            <a:avLst/>
-          </a:prstGeom>
-          <a:solidFill>
-            <a:srgbClr val="EFF6FF"/>
-          </a:solidFill>
-          <a:ln w="9525">
-            <a:solidFill>
-              <a:srgbClr val="BFDBFE"/>
-            </a:solidFill>
-          </a:ln>
-        </p:spPr>
-        <p:txBody>
-          <a:bodyPr wrap="square" anchor="t" lIns="91440" tIns="68580" rIns="91440" bIns="68580"/>
-          <a:lstStyle/>
-          <a:p>
-            <a:pPr marL="285750" indent="-171450">
-              <a:buChar char="•"/>
-            </a:pPr>
-            <a:r>
-              <a:rPr lang="ko-KR" sz="1500">
-                <a:solidFill>
-                  <a:srgbClr val="0F172A"/>
-                </a:solidFill>
-                <a:latin typeface="Aptos"/>
-                <a:ea typeface="Malgun Gothic"/>
-              </a:rPr>
-              <a:t>결제금액/취소금액/수수료/최종 정산금액 동일</a:t>
-            </a:r>
-          </a:p>
-          <a:p>
-            <a:pPr marL="285750" indent="-171450">
-              <a:buChar char="•"/>
-            </a:pPr>
-            <a:r>
-              <a:rPr lang="ko-KR" sz="1500">
-                <a:solidFill>
-                  <a:srgbClr val="0F172A"/>
-                </a:solidFill>
-                <a:latin typeface="Aptos"/>
-                <a:ea typeface="Malgun Gothic"/>
-              </a:rPr>
-              <a:t>중복 실행 차단과 실패 이력 보존</a:t>
-            </a:r>
-          </a:p>
-          <a:p>
-            <a:pPr marL="285750" indent="-171450">
-              <a:buChar char="•"/>
-            </a:pPr>
-            <a:r>
-              <a:rPr lang="ko-KR" sz="1500">
-                <a:solidFill>
-                  <a:srgbClr val="0F172A"/>
-                </a:solidFill>
-                <a:latin typeface="Aptos"/>
-                <a:ea typeface="Malgun Gothic"/>
-              </a:rPr>
-              <a:t>성능과 정합성을 함께 검증</a:t>
-            </a:r>
-          </a:p>
-        </p:txBody>
-      </p:sp>
-      <p:sp>
-        <p:nvSpPr>
-          <p:cNvPr id="11" name="Shape 11"/>
           <p:cNvSpPr txBox="1"/>
           <p:nvPr/>
         </p:nvSpPr>
@@ -5291,14 +5897,14 @@
                 <a:latin typeface="Aptos"/>
                 <a:ea typeface="Malgun Gothic"/>
               </a:rPr>
-              <a:t>결과 요약</a:t>
-            </a:r>
-          </a:p>
-        </p:txBody>
-      </p:sp>
-      <p:sp>
-        <p:nvSpPr>
-          <p:cNvPr id="12" name="Shape 12"/>
+              <a:t>저장 병목</a:t>
+            </a:r>
+          </a:p>
+        </p:txBody>
+      </p:sp>
+      <p:sp>
+        <p:nvSpPr>
+          <p:cNvPr id="11" name="Shape 11"/>
           <p:cNvSpPr txBox="1"/>
           <p:nvPr/>
         </p:nvSpPr>

</xml_diff>